<commit_message>
Add compose layout for multiple panels on one slide.
Support cols/rows/grid/main-side/header-body arrangements with nested layouts that share slide chrome.

Co-authored-by: Cursor <cursoragent@cursor.com>
</commit_message>
<xml_diff>
--- a/examples/template-gallery.pptx
+++ b/examples/template-gallery.pptx
@@ -17,9 +17,11 @@
     <p:sldId id="265" r:id="rId11"/>
     <p:sldId id="266" r:id="rId12"/>
     <p:sldId id="267" r:id="rId13"/>
+    <p:sldId id="268" r:id="rId14"/>
+    <p:sldId id="269" r:id="rId15"/>
   </p:sldIdLst>
   <p:notesMasterIdLst>
-    <p:notesMasterId r:id="rId14"/>
+    <p:notesMasterId r:id="rId16"/>
   </p:notesMasterIdLst>
   <p:sldSz cx="12191695" cy="6858000"/>
   <p:notesSz cx="6858000" cy="12191695"/>
@@ -801,6 +803,182 @@
             <a:fld id="{F7021451-1387-4CA6-816F-3879F97B5CBC}" type="slidenum">
               <a:rPr lang="en-US"/>
               <a:t>12</a:t>
+            </a:fld>
+            <a:endParaRPr lang="en-US"/>
+          </a:p>
+        </p:txBody>
+      </p:sp>
+    </p:spTree>
+    <p:extLst>
+      <p:ext uri="{BB962C8B-B14F-4D97-AF65-F5344CB8AC3E}">
+        <p14:creationId xmlns:p14="http://schemas.microsoft.com/office/powerpoint/2010/main" val="1024086991"/>
+      </p:ext>
+    </p:extLst>
+  </p:cSld>
+  <p:clrMapOvr>
+    <a:masterClrMapping/>
+  </p:clrMapOvr>
+</p:notes>
+</file>
+
+<file path=ppt/notesSlides/notesSlide13.xml><?xml version="1.0" encoding="utf-8"?>
+<p:notes xmlns:a="http://schemas.openxmlformats.org/drawingml/2006/main" xmlns:r="http://schemas.openxmlformats.org/officeDocument/2006/relationships" xmlns:p="http://schemas.openxmlformats.org/presentationml/2006/main">
+  <p:cSld>
+    <p:spTree>
+      <p:nvGrpSpPr>
+        <p:cNvPr id="1" name=""/>
+        <p:cNvGrpSpPr/>
+        <p:nvPr/>
+      </p:nvGrpSpPr>
+      <p:grpSpPr>
+        <a:xfrm>
+          <a:off x="0" y="0"/>
+          <a:ext cx="0" cy="0"/>
+          <a:chOff x="0" y="0"/>
+          <a:chExt cx="0" cy="0"/>
+        </a:xfrm>
+      </p:grpSpPr>
+      <p:sp>
+        <p:nvSpPr>
+          <p:cNvPr id="2" name="Slide Image Placeholder 1"/>
+          <p:cNvSpPr>
+            <a:spLocks noGrp="1" noRot="1" noChangeAspect="1"/>
+          </p:cNvSpPr>
+          <p:nvPr>
+            <p:ph type="sldImg"/>
+          </p:nvPr>
+        </p:nvSpPr>
+        <p:spPr/>
+      </p:sp>
+      <p:sp>
+        <p:nvSpPr>
+          <p:cNvPr id="3" name="Notes Placeholder 2"/>
+          <p:cNvSpPr>
+            <a:spLocks noGrp="1"/>
+          </p:cNvSpPr>
+          <p:nvPr>
+            <p:ph type="body" idx="1"/>
+          </p:nvPr>
+        </p:nvSpPr>
+        <p:spPr/>
+        <p:txBody>
+          <a:bodyPr/>
+          <a:lstStyle/>
+          <a:p>
+            <a:r>
+              <a:rPr lang="en-US" dirty="0"/>
+              <a:t/>
+            </a:r>
+            <a:endParaRPr lang="en-US" dirty="0"/>
+          </a:p>
+        </p:txBody>
+      </p:sp>
+      <p:sp>
+        <p:nvSpPr>
+          <p:cNvPr id="4" name="Slide Number Placeholder 3"/>
+          <p:cNvSpPr>
+            <a:spLocks noGrp="1"/>
+          </p:cNvSpPr>
+          <p:nvPr>
+            <p:ph type="sldNum" sz="quarter" idx="10"/>
+          </p:nvPr>
+        </p:nvSpPr>
+        <p:spPr/>
+        <p:txBody>
+          <a:bodyPr/>
+          <a:lstStyle/>
+          <a:p>
+            <a:fld id="{F7021451-1387-4CA6-816F-3879F97B5CBC}" type="slidenum">
+              <a:rPr lang="en-US"/>
+              <a:t>13</a:t>
+            </a:fld>
+            <a:endParaRPr lang="en-US"/>
+          </a:p>
+        </p:txBody>
+      </p:sp>
+    </p:spTree>
+    <p:extLst>
+      <p:ext uri="{BB962C8B-B14F-4D97-AF65-F5344CB8AC3E}">
+        <p14:creationId xmlns:p14="http://schemas.microsoft.com/office/powerpoint/2010/main" val="1024086991"/>
+      </p:ext>
+    </p:extLst>
+  </p:cSld>
+  <p:clrMapOvr>
+    <a:masterClrMapping/>
+  </p:clrMapOvr>
+</p:notes>
+</file>
+
+<file path=ppt/notesSlides/notesSlide14.xml><?xml version="1.0" encoding="utf-8"?>
+<p:notes xmlns:a="http://schemas.openxmlformats.org/drawingml/2006/main" xmlns:r="http://schemas.openxmlformats.org/officeDocument/2006/relationships" xmlns:p="http://schemas.openxmlformats.org/presentationml/2006/main">
+  <p:cSld>
+    <p:spTree>
+      <p:nvGrpSpPr>
+        <p:cNvPr id="1" name=""/>
+        <p:cNvGrpSpPr/>
+        <p:nvPr/>
+      </p:nvGrpSpPr>
+      <p:grpSpPr>
+        <a:xfrm>
+          <a:off x="0" y="0"/>
+          <a:ext cx="0" cy="0"/>
+          <a:chOff x="0" y="0"/>
+          <a:chExt cx="0" cy="0"/>
+        </a:xfrm>
+      </p:grpSpPr>
+      <p:sp>
+        <p:nvSpPr>
+          <p:cNvPr id="2" name="Slide Image Placeholder 1"/>
+          <p:cNvSpPr>
+            <a:spLocks noGrp="1" noRot="1" noChangeAspect="1"/>
+          </p:cNvSpPr>
+          <p:nvPr>
+            <p:ph type="sldImg"/>
+          </p:nvPr>
+        </p:nvSpPr>
+        <p:spPr/>
+      </p:sp>
+      <p:sp>
+        <p:nvSpPr>
+          <p:cNvPr id="3" name="Notes Placeholder 2"/>
+          <p:cNvSpPr>
+            <a:spLocks noGrp="1"/>
+          </p:cNvSpPr>
+          <p:nvPr>
+            <p:ph type="body" idx="1"/>
+          </p:nvPr>
+        </p:nvSpPr>
+        <p:spPr/>
+        <p:txBody>
+          <a:bodyPr/>
+          <a:lstStyle/>
+          <a:p>
+            <a:r>
+              <a:rPr lang="en-US" dirty="0"/>
+              <a:t/>
+            </a:r>
+            <a:endParaRPr lang="en-US" dirty="0"/>
+          </a:p>
+        </p:txBody>
+      </p:sp>
+      <p:sp>
+        <p:nvSpPr>
+          <p:cNvPr id="4" name="Slide Number Placeholder 3"/>
+          <p:cNvSpPr>
+            <a:spLocks noGrp="1"/>
+          </p:cNvSpPr>
+          <p:nvPr>
+            <p:ph type="sldNum" sz="quarter" idx="10"/>
+          </p:nvPr>
+        </p:nvSpPr>
+        <p:spPr/>
+        <p:txBody>
+          <a:bodyPr/>
+          <a:lstStyle/>
+          <a:p>
+            <a:fld id="{F7021451-1387-4CA6-816F-3879F97B5CBC}" type="slidenum">
+              <a:rPr lang="en-US"/>
+              <a:t>14</a:t>
             </a:fld>
             <a:endParaRPr lang="en-US"/>
           </a:p>
@@ -4288,8 +4466,8 @@
         </p:nvSpPr>
         <p:spPr>
           <a:xfrm>
-            <a:off x="400050" y="457200"/>
-            <a:ext cx="1905000" cy="171450"/>
+            <a:off x="400050" y="247650"/>
+            <a:ext cx="10877550" cy="381000"/>
           </a:xfrm>
           <a:prstGeom prst="rect">
             <a:avLst/>
@@ -4305,140 +4483,23 @@
               <a:buNone/>
             </a:pPr>
             <a:r>
-              <a:rPr lang="en-US" sz="1100" b="1" dirty="0">
-                <a:solidFill>
-                  <a:srgbClr val="E94560"/>
-                </a:solidFill>
-                <a:latin typeface="Helvetica Neue" pitchFamily="34" charset="0"/>
-                <a:ea typeface="Helvetica Neue" pitchFamily="34" charset="-122"/>
-                <a:cs typeface="Helvetica Neue" pitchFamily="34" charset="-120"/>
-              </a:rPr>
-              <a:t>NEXT</a:t>
-            </a:r>
-            <a:endParaRPr lang="en-US" sz="1100" dirty="0"/>
+              <a:rPr lang="en-US" sz="3000" b="1" dirty="0">
+                <a:solidFill>
+                  <a:srgbClr val="EAEAEA"/>
+                </a:solidFill>
+                <a:latin typeface="Helvetica Neue" pitchFamily="34" charset="0"/>
+                <a:ea typeface="Helvetica Neue" pitchFamily="34" charset="-122"/>
+                <a:cs typeface="Helvetica Neue" pitchFamily="34" charset="-120"/>
+              </a:rPr>
+              <a:t>Compose — two-up (columns)</a:t>
+            </a:r>
+            <a:endParaRPr lang="en-US" sz="3000" dirty="0"/>
           </a:p>
         </p:txBody>
       </p:sp>
       <p:sp>
         <p:nvSpPr>
           <p:cNvPr id="4" name="Text 1"/>
-          <p:cNvSpPr/>
-          <p:nvPr/>
-        </p:nvSpPr>
-        <p:spPr>
-          <a:xfrm>
-            <a:off x="400050" y="1238250"/>
-            <a:ext cx="9525000" cy="1333500"/>
-          </a:xfrm>
-          <a:prstGeom prst="rect">
-            <a:avLst/>
-          </a:prstGeom>
-          <a:noFill/>
-          <a:ln/>
-        </p:spPr>
-        <p:txBody>
-          <a:bodyPr wrap="square" lIns="0" tIns="0" rIns="0" bIns="0" rtlCol="0" anchor="t"/>
-          <a:lstStyle/>
-          <a:p>
-            <a:pPr algn="l" indent="0" marL="0">
-              <a:buNone/>
-            </a:pPr>
-            <a:r>
-              <a:rPr lang="en-US" sz="4000" b="1" dirty="0">
-                <a:solidFill>
-                  <a:srgbClr val="EAEAEA"/>
-                </a:solidFill>
-                <a:latin typeface="Helvetica Neue" pitchFamily="34" charset="0"/>
-                <a:ea typeface="Helvetica Neue" pitchFamily="34" charset="-122"/>
-                <a:cs typeface="Helvetica Neue" pitchFamily="34" charset="-120"/>
-              </a:rPr>
-              <a:t>Author in YAML. Render with ppt-gen.</a:t>
-            </a:r>
-            <a:endParaRPr lang="en-US" sz="4000" dirty="0"/>
-          </a:p>
-        </p:txBody>
-      </p:sp>
-      <p:sp>
-        <p:nvSpPr>
-          <p:cNvPr id="5" name="Text 2"/>
-          <p:cNvSpPr/>
-          <p:nvPr/>
-        </p:nvSpPr>
-        <p:spPr>
-          <a:xfrm>
-            <a:off x="400050" y="2952750"/>
-            <a:ext cx="8572500" cy="571500"/>
-          </a:xfrm>
-          <a:prstGeom prst="rect">
-            <a:avLst/>
-          </a:prstGeom>
-          <a:noFill/>
-          <a:ln/>
-        </p:spPr>
-        <p:txBody>
-          <a:bodyPr wrap="square" lIns="0" tIns="0" rIns="0" bIns="0" rtlCol="0" anchor="t"/>
-          <a:lstStyle/>
-          <a:p>
-            <a:pPr algn="l" indent="0" marL="0">
-              <a:buNone/>
-            </a:pPr>
-            <a:r>
-              <a:rPr lang="en-US" sz="2000" dirty="0">
-                <a:solidFill>
-                  <a:srgbClr val="6C6C8A"/>
-                </a:solidFill>
-                <a:latin typeface="Helvetica Neue" pitchFamily="34" charset="0"/>
-                <a:ea typeface="Helvetica Neue" pitchFamily="34" charset="-122"/>
-                <a:cs typeface="Helvetica Neue" pitchFamily="34" charset="-120"/>
-              </a:rPr>
-              <a:t>Pick a pack layout, fill items, regenerate — same visual language every time.</a:t>
-            </a:r>
-            <a:endParaRPr lang="en-US" sz="2000" dirty="0"/>
-          </a:p>
-        </p:txBody>
-      </p:sp>
-      <p:sp>
-        <p:nvSpPr>
-          <p:cNvPr id="6" name="Text 3"/>
-          <p:cNvSpPr/>
-          <p:nvPr/>
-        </p:nvSpPr>
-        <p:spPr>
-          <a:xfrm>
-            <a:off x="400050" y="5619750"/>
-            <a:ext cx="10477500" cy="342900"/>
-          </a:xfrm>
-          <a:prstGeom prst="rect">
-            <a:avLst/>
-          </a:prstGeom>
-          <a:noFill/>
-          <a:ln/>
-        </p:spPr>
-        <p:txBody>
-          <a:bodyPr wrap="square" lIns="0" tIns="0" rIns="0" bIns="0" rtlCol="0" anchor="t"/>
-          <a:lstStyle/>
-          <a:p>
-            <a:pPr algn="l" indent="0" marL="0">
-              <a:buNone/>
-            </a:pPr>
-            <a:r>
-              <a:rPr lang="en-US" sz="1700" b="1" dirty="0">
-                <a:solidFill>
-                  <a:srgbClr val="EAEAEA"/>
-                </a:solidFill>
-                <a:latin typeface="Helvetica Neue" pitchFamily="34" charset="0"/>
-                <a:ea typeface="Helvetica Neue" pitchFamily="34" charset="-122"/>
-                <a:cs typeface="Helvetica Neue" pitchFamily="34" charset="-120"/>
-              </a:rPr>
-              <a:t>See README · Template packs (consulting / scientific / core)</a:t>
-            </a:r>
-            <a:endParaRPr lang="en-US" sz="1700" dirty="0"/>
-          </a:p>
-        </p:txBody>
-      </p:sp>
-      <p:sp>
-        <p:nvSpPr>
-          <p:cNvPr id="7" name="Text 4"/>
           <p:cNvSpPr/>
           <p:nvPr/>
         </p:nvSpPr>
@@ -4477,7 +4538,7 @@
       </p:sp>
       <p:sp>
         <p:nvSpPr>
-          <p:cNvPr id="8" name="Shape 5"/>
+          <p:cNvPr id="5" name="Shape 2"/>
           <p:cNvSpPr/>
           <p:nvPr/>
         </p:nvSpPr>
@@ -4504,7 +4565,7 @@
       </p:sp>
       <p:sp>
         <p:nvSpPr>
-          <p:cNvPr id="9" name="Text 6"/>
+          <p:cNvPr id="6" name="Text 3"/>
           <p:cNvSpPr/>
           <p:nvPr/>
         </p:nvSpPr>
@@ -4543,7 +4604,7 @@
       </p:sp>
       <p:sp>
         <p:nvSpPr>
-          <p:cNvPr id="10" name="Text 7"/>
+          <p:cNvPr id="7" name="Text 4"/>
           <p:cNvSpPr/>
           <p:nvPr/>
         </p:nvSpPr>
@@ -4575,6 +4636,2291 @@
                 <a:cs typeface="Helvetica Neue" pitchFamily="34" charset="-120"/>
               </a:rPr>
               <a:t>12</a:t>
+            </a:r>
+            <a:endParaRPr lang="en-US" sz="1200" dirty="0"/>
+          </a:p>
+        </p:txBody>
+      </p:sp>
+      <p:sp>
+        <p:nvSpPr>
+          <p:cNvPr id="8" name="Text 5"/>
+          <p:cNvSpPr/>
+          <p:nvPr/>
+        </p:nvSpPr>
+        <p:spPr>
+          <a:xfrm>
+            <a:off x="400050" y="819150"/>
+            <a:ext cx="5619750" cy="171450"/>
+          </a:xfrm>
+          <a:prstGeom prst="rect">
+            <a:avLst/>
+          </a:prstGeom>
+          <a:noFill/>
+          <a:ln/>
+        </p:spPr>
+        <p:txBody>
+          <a:bodyPr wrap="square" lIns="0" tIns="0" rIns="0" bIns="0" rtlCol="0" anchor="t"/>
+          <a:lstStyle/>
+          <a:p>
+            <a:pPr algn="l" indent="0" marL="0">
+              <a:buNone/>
+            </a:pPr>
+            <a:r>
+              <a:rPr lang="en-US" sz="1100" b="1" dirty="0">
+                <a:solidFill>
+                  <a:srgbClr val="6C6C8A"/>
+                </a:solidFill>
+                <a:latin typeface="Helvetica Neue" pitchFamily="34" charset="0"/>
+                <a:ea typeface="Helvetica Neue" pitchFamily="34" charset="-122"/>
+                <a:cs typeface="Helvetica Neue" pitchFamily="34" charset="-120"/>
+              </a:rPr>
+              <a:t>OUTCOMES</a:t>
+            </a:r>
+            <a:endParaRPr lang="en-US" sz="1100" dirty="0"/>
+          </a:p>
+        </p:txBody>
+      </p:sp>
+      <p:sp>
+        <p:nvSpPr>
+          <p:cNvPr id="9" name="Shape 6"/>
+          <p:cNvSpPr/>
+          <p:nvPr/>
+        </p:nvSpPr>
+        <p:spPr>
+          <a:xfrm>
+            <a:off x="400050" y="2247900"/>
+            <a:ext cx="2695575" cy="2857500"/>
+          </a:xfrm>
+          <a:prstGeom prst="roundRect">
+            <a:avLst>
+              <a:gd name="adj" fmla="val 3392"/>
+            </a:avLst>
+          </a:prstGeom>
+          <a:solidFill>
+            <a:srgbClr val="2B2B4A"/>
+          </a:solidFill>
+          <a:ln w="12700">
+            <a:solidFill>
+              <a:srgbClr val="2B2B4A"/>
+            </a:solidFill>
+            <a:prstDash val="solid"/>
+          </a:ln>
+        </p:spPr>
+      </p:sp>
+      <p:sp>
+        <p:nvSpPr>
+          <p:cNvPr id="10" name="Shape 7"/>
+          <p:cNvSpPr/>
+          <p:nvPr/>
+        </p:nvSpPr>
+        <p:spPr>
+          <a:xfrm>
+            <a:off x="400050" y="2247900"/>
+            <a:ext cx="2695575" cy="76200"/>
+          </a:xfrm>
+          <a:prstGeom prst="rect">
+            <a:avLst/>
+          </a:prstGeom>
+          <a:solidFill>
+            <a:srgbClr val="4E79A7"/>
+          </a:solidFill>
+          <a:ln w="12700">
+            <a:solidFill>
+              <a:srgbClr val="4E79A7"/>
+            </a:solidFill>
+            <a:prstDash val="solid"/>
+          </a:ln>
+        </p:spPr>
+      </p:sp>
+      <p:sp>
+        <p:nvSpPr>
+          <p:cNvPr id="11" name="Text 8"/>
+          <p:cNvSpPr/>
+          <p:nvPr/>
+        </p:nvSpPr>
+        <p:spPr>
+          <a:xfrm>
+            <a:off x="590550" y="2495550"/>
+            <a:ext cx="2314575" cy="171450"/>
+          </a:xfrm>
+          <a:prstGeom prst="rect">
+            <a:avLst/>
+          </a:prstGeom>
+          <a:noFill/>
+          <a:ln/>
+        </p:spPr>
+        <p:txBody>
+          <a:bodyPr wrap="square" lIns="0" tIns="0" rIns="0" bIns="0" rtlCol="0" anchor="t"/>
+          <a:lstStyle/>
+          <a:p>
+            <a:pPr algn="l" indent="0" marL="0">
+              <a:buNone/>
+            </a:pPr>
+            <a:r>
+              <a:rPr lang="en-US" sz="1100" b="1" dirty="0">
+                <a:solidFill>
+                  <a:srgbClr val="6C6C8A"/>
+                </a:solidFill>
+                <a:latin typeface="Helvetica Neue" pitchFamily="34" charset="0"/>
+                <a:ea typeface="Helvetica Neue" pitchFamily="34" charset="-122"/>
+                <a:cs typeface="Helvetica Neue" pitchFamily="34" charset="-120"/>
+              </a:rPr>
+              <a:t>LATENCY</a:t>
+            </a:r>
+            <a:endParaRPr lang="en-US" sz="1100" dirty="0"/>
+          </a:p>
+        </p:txBody>
+      </p:sp>
+      <p:sp>
+        <p:nvSpPr>
+          <p:cNvPr id="12" name="Text 9"/>
+          <p:cNvSpPr/>
+          <p:nvPr/>
+        </p:nvSpPr>
+        <p:spPr>
+          <a:xfrm>
+            <a:off x="590550" y="2895600"/>
+            <a:ext cx="2314575" cy="1524000"/>
+          </a:xfrm>
+          <a:prstGeom prst="rect">
+            <a:avLst/>
+          </a:prstGeom>
+          <a:noFill/>
+          <a:ln/>
+        </p:spPr>
+        <p:txBody>
+          <a:bodyPr wrap="none" lIns="0" tIns="0" rIns="0" bIns="0" rtlCol="0" anchor="ctr"/>
+          <a:lstStyle/>
+          <a:p>
+            <a:pPr algn="l" indent="0" marL="0">
+              <a:buNone/>
+            </a:pPr>
+            <a:r>
+              <a:rPr lang="en-US" sz="4000" b="1" dirty="0">
+                <a:solidFill>
+                  <a:srgbClr val="4E79A7"/>
+                </a:solidFill>
+                <a:latin typeface="Helvetica Neue" pitchFamily="34" charset="0"/>
+                <a:ea typeface="Helvetica Neue" pitchFamily="34" charset="-122"/>
+                <a:cs typeface="Helvetica Neue" pitchFamily="34" charset="-120"/>
+              </a:rPr>
+              <a:t>−38%</a:t>
+            </a:r>
+            <a:endParaRPr lang="en-US" sz="4000" dirty="0"/>
+          </a:p>
+        </p:txBody>
+      </p:sp>
+      <p:sp>
+        <p:nvSpPr>
+          <p:cNvPr id="13" name="Text 10"/>
+          <p:cNvSpPr/>
+          <p:nvPr/>
+        </p:nvSpPr>
+        <p:spPr>
+          <a:xfrm>
+            <a:off x="590550" y="4552950"/>
+            <a:ext cx="2314575" cy="381000"/>
+          </a:xfrm>
+          <a:prstGeom prst="rect">
+            <a:avLst/>
+          </a:prstGeom>
+          <a:noFill/>
+          <a:ln/>
+        </p:spPr>
+        <p:txBody>
+          <a:bodyPr wrap="square" lIns="0" tIns="0" rIns="0" bIns="0" rtlCol="0" anchor="t"/>
+          <a:lstStyle/>
+          <a:p>
+            <a:pPr algn="l" indent="0" marL="0">
+              <a:buNone/>
+            </a:pPr>
+            <a:r>
+              <a:rPr lang="en-US" sz="1300" dirty="0">
+                <a:solidFill>
+                  <a:srgbClr val="6C6C8A"/>
+                </a:solidFill>
+                <a:latin typeface="Helvetica Neue" pitchFamily="34" charset="0"/>
+                <a:ea typeface="Helvetica Neue" pitchFamily="34" charset="-122"/>
+                <a:cs typeface="Helvetica Neue" pitchFamily="34" charset="-120"/>
+              </a:rPr>
+              <a:t>p50</a:t>
+            </a:r>
+            <a:endParaRPr lang="en-US" sz="1300" dirty="0"/>
+          </a:p>
+        </p:txBody>
+      </p:sp>
+      <p:sp>
+        <p:nvSpPr>
+          <p:cNvPr id="14" name="Shape 11"/>
+          <p:cNvSpPr/>
+          <p:nvPr/>
+        </p:nvSpPr>
+        <p:spPr>
+          <a:xfrm>
+            <a:off x="3324225" y="2247900"/>
+            <a:ext cx="2695575" cy="2857500"/>
+          </a:xfrm>
+          <a:prstGeom prst="roundRect">
+            <a:avLst>
+              <a:gd name="adj" fmla="val 3392"/>
+            </a:avLst>
+          </a:prstGeom>
+          <a:solidFill>
+            <a:srgbClr val="2B2B4A"/>
+          </a:solidFill>
+          <a:ln w="12700">
+            <a:solidFill>
+              <a:srgbClr val="2B2B4A"/>
+            </a:solidFill>
+            <a:prstDash val="solid"/>
+          </a:ln>
+        </p:spPr>
+      </p:sp>
+      <p:sp>
+        <p:nvSpPr>
+          <p:cNvPr id="15" name="Shape 12"/>
+          <p:cNvSpPr/>
+          <p:nvPr/>
+        </p:nvSpPr>
+        <p:spPr>
+          <a:xfrm>
+            <a:off x="3324225" y="2247900"/>
+            <a:ext cx="2695575" cy="76200"/>
+          </a:xfrm>
+          <a:prstGeom prst="rect">
+            <a:avLst/>
+          </a:prstGeom>
+          <a:solidFill>
+            <a:srgbClr val="F28E2B"/>
+          </a:solidFill>
+          <a:ln w="12700">
+            <a:solidFill>
+              <a:srgbClr val="F28E2B"/>
+            </a:solidFill>
+            <a:prstDash val="solid"/>
+          </a:ln>
+        </p:spPr>
+      </p:sp>
+      <p:sp>
+        <p:nvSpPr>
+          <p:cNvPr id="16" name="Text 13"/>
+          <p:cNvSpPr/>
+          <p:nvPr/>
+        </p:nvSpPr>
+        <p:spPr>
+          <a:xfrm>
+            <a:off x="3514725" y="2495550"/>
+            <a:ext cx="2314575" cy="171450"/>
+          </a:xfrm>
+          <a:prstGeom prst="rect">
+            <a:avLst/>
+          </a:prstGeom>
+          <a:noFill/>
+          <a:ln/>
+        </p:spPr>
+        <p:txBody>
+          <a:bodyPr wrap="square" lIns="0" tIns="0" rIns="0" bIns="0" rtlCol="0" anchor="t"/>
+          <a:lstStyle/>
+          <a:p>
+            <a:pPr algn="l" indent="0" marL="0">
+              <a:buNone/>
+            </a:pPr>
+            <a:r>
+              <a:rPr lang="en-US" sz="1100" b="1" dirty="0">
+                <a:solidFill>
+                  <a:srgbClr val="6C6C8A"/>
+                </a:solidFill>
+                <a:latin typeface="Helvetica Neue" pitchFamily="34" charset="0"/>
+                <a:ea typeface="Helvetica Neue" pitchFamily="34" charset="-122"/>
+                <a:cs typeface="Helvetica Neue" pitchFamily="34" charset="-120"/>
+              </a:rPr>
+              <a:t>QUALITY</a:t>
+            </a:r>
+            <a:endParaRPr lang="en-US" sz="1100" dirty="0"/>
+          </a:p>
+        </p:txBody>
+      </p:sp>
+      <p:sp>
+        <p:nvSpPr>
+          <p:cNvPr id="17" name="Text 14"/>
+          <p:cNvSpPr/>
+          <p:nvPr/>
+        </p:nvSpPr>
+        <p:spPr>
+          <a:xfrm>
+            <a:off x="3514725" y="2895600"/>
+            <a:ext cx="2314575" cy="1524000"/>
+          </a:xfrm>
+          <a:prstGeom prst="rect">
+            <a:avLst/>
+          </a:prstGeom>
+          <a:noFill/>
+          <a:ln/>
+        </p:spPr>
+        <p:txBody>
+          <a:bodyPr wrap="none" lIns="0" tIns="0" rIns="0" bIns="0" rtlCol="0" anchor="ctr"/>
+          <a:lstStyle/>
+          <a:p>
+            <a:pPr algn="l" indent="0" marL="0">
+              <a:buNone/>
+            </a:pPr>
+            <a:r>
+              <a:rPr lang="en-US" sz="4000" b="1" dirty="0">
+                <a:solidFill>
+                  <a:srgbClr val="F28E2B"/>
+                </a:solidFill>
+                <a:latin typeface="Helvetica Neue" pitchFamily="34" charset="0"/>
+                <a:ea typeface="Helvetica Neue" pitchFamily="34" charset="-122"/>
+                <a:cs typeface="Helvetica Neue" pitchFamily="34" charset="-120"/>
+              </a:rPr>
+              <a:t>+0.12</a:t>
+            </a:r>
+            <a:endParaRPr lang="en-US" sz="4000" dirty="0"/>
+          </a:p>
+        </p:txBody>
+      </p:sp>
+      <p:sp>
+        <p:nvSpPr>
+          <p:cNvPr id="18" name="Text 15"/>
+          <p:cNvSpPr/>
+          <p:nvPr/>
+        </p:nvSpPr>
+        <p:spPr>
+          <a:xfrm>
+            <a:off x="3514725" y="4552950"/>
+            <a:ext cx="2314575" cy="381000"/>
+          </a:xfrm>
+          <a:prstGeom prst="rect">
+            <a:avLst/>
+          </a:prstGeom>
+          <a:noFill/>
+          <a:ln/>
+        </p:spPr>
+        <p:txBody>
+          <a:bodyPr wrap="square" lIns="0" tIns="0" rIns="0" bIns="0" rtlCol="0" anchor="t"/>
+          <a:lstStyle/>
+          <a:p>
+            <a:pPr algn="l" indent="0" marL="0">
+              <a:buNone/>
+            </a:pPr>
+            <a:r>
+              <a:rPr lang="en-US" sz="1300" dirty="0">
+                <a:solidFill>
+                  <a:srgbClr val="6C6C8A"/>
+                </a:solidFill>
+                <a:latin typeface="Helvetica Neue" pitchFamily="34" charset="0"/>
+                <a:ea typeface="Helvetica Neue" pitchFamily="34" charset="-122"/>
+                <a:cs typeface="Helvetica Neue" pitchFamily="34" charset="-120"/>
+              </a:rPr>
+              <a:t>Win rate</a:t>
+            </a:r>
+            <a:endParaRPr lang="en-US" sz="1300" dirty="0"/>
+          </a:p>
+        </p:txBody>
+      </p:sp>
+      <p:sp>
+        <p:nvSpPr>
+          <p:cNvPr id="19" name="Text 16"/>
+          <p:cNvSpPr/>
+          <p:nvPr/>
+        </p:nvSpPr>
+        <p:spPr>
+          <a:xfrm>
+            <a:off x="6172200" y="819150"/>
+            <a:ext cx="5619750" cy="171450"/>
+          </a:xfrm>
+          <a:prstGeom prst="rect">
+            <a:avLst/>
+          </a:prstGeom>
+          <a:noFill/>
+          <a:ln/>
+        </p:spPr>
+        <p:txBody>
+          <a:bodyPr wrap="square" lIns="0" tIns="0" rIns="0" bIns="0" rtlCol="0" anchor="t"/>
+          <a:lstStyle/>
+          <a:p>
+            <a:pPr algn="l" indent="0" marL="0">
+              <a:buNone/>
+            </a:pPr>
+            <a:r>
+              <a:rPr lang="en-US" sz="1100" b="1" dirty="0">
+                <a:solidFill>
+                  <a:srgbClr val="6C6C8A"/>
+                </a:solidFill>
+                <a:latin typeface="Helvetica Neue" pitchFamily="34" charset="0"/>
+                <a:ea typeface="Helvetica Neue" pitchFamily="34" charset="-122"/>
+                <a:cs typeface="Helvetica Neue" pitchFamily="34" charset="-120"/>
+              </a:rPr>
+              <a:t>PATH</a:t>
+            </a:r>
+            <a:endParaRPr lang="en-US" sz="1100" dirty="0"/>
+          </a:p>
+        </p:txBody>
+      </p:sp>
+      <p:sp>
+        <p:nvSpPr>
+          <p:cNvPr id="20" name="Shape 17"/>
+          <p:cNvSpPr/>
+          <p:nvPr/>
+        </p:nvSpPr>
+        <p:spPr>
+          <a:xfrm>
+            <a:off x="6172200" y="2533650"/>
+            <a:ext cx="1790700" cy="800100"/>
+          </a:xfrm>
+          <a:prstGeom prst="chevron">
+            <a:avLst/>
+          </a:prstGeom>
+          <a:solidFill>
+            <a:srgbClr val="4E79A7"/>
+          </a:solidFill>
+          <a:ln w="12700">
+            <a:solidFill>
+              <a:srgbClr val="4E79A7"/>
+            </a:solidFill>
+            <a:prstDash val="solid"/>
+          </a:ln>
+        </p:spPr>
+      </p:sp>
+      <p:sp>
+        <p:nvSpPr>
+          <p:cNvPr id="21" name="Text 18"/>
+          <p:cNvSpPr/>
+          <p:nvPr/>
+        </p:nvSpPr>
+        <p:spPr>
+          <a:xfrm>
+            <a:off x="6438900" y="2533650"/>
+            <a:ext cx="1104900" cy="800100"/>
+          </a:xfrm>
+          <a:prstGeom prst="rect">
+            <a:avLst/>
+          </a:prstGeom>
+          <a:noFill/>
+          <a:ln/>
+        </p:spPr>
+        <p:txBody>
+          <a:bodyPr wrap="square" lIns="0" tIns="0" rIns="0" bIns="0" rtlCol="0" anchor="ctr"/>
+          <a:lstStyle/>
+          <a:p>
+            <a:pPr algn="ctr" indent="0" marL="0">
+              <a:buNone/>
+            </a:pPr>
+            <a:r>
+              <a:rPr lang="en-US" sz="1400" b="1" dirty="0">
+                <a:solidFill>
+                  <a:srgbClr val="FFFFFF"/>
+                </a:solidFill>
+                <a:latin typeface="Helvetica Neue" pitchFamily="34" charset="0"/>
+                <a:ea typeface="Helvetica Neue" pitchFamily="34" charset="-122"/>
+                <a:cs typeface="Helvetica Neue" pitchFamily="34" charset="-120"/>
+              </a:rPr>
+              <a:t>Frame</a:t>
+            </a:r>
+            <a:endParaRPr lang="en-US" sz="1400" dirty="0"/>
+          </a:p>
+        </p:txBody>
+      </p:sp>
+      <p:sp>
+        <p:nvSpPr>
+          <p:cNvPr id="22" name="Shape 19"/>
+          <p:cNvSpPr/>
+          <p:nvPr/>
+        </p:nvSpPr>
+        <p:spPr>
+          <a:xfrm>
+            <a:off x="6172200" y="3486150"/>
+            <a:ext cx="1790700" cy="1333500"/>
+          </a:xfrm>
+          <a:prstGeom prst="roundRect">
+            <a:avLst>
+              <a:gd name="adj" fmla="val 6857"/>
+            </a:avLst>
+          </a:prstGeom>
+          <a:solidFill>
+            <a:srgbClr val="2B2B4A"/>
+          </a:solidFill>
+          <a:ln w="12700">
+            <a:solidFill>
+              <a:srgbClr val="2B2B4A"/>
+            </a:solidFill>
+            <a:prstDash val="solid"/>
+          </a:ln>
+        </p:spPr>
+      </p:sp>
+      <p:sp>
+        <p:nvSpPr>
+          <p:cNvPr id="23" name="Shape 20"/>
+          <p:cNvSpPr/>
+          <p:nvPr/>
+        </p:nvSpPr>
+        <p:spPr>
+          <a:xfrm>
+            <a:off x="6172200" y="3486150"/>
+            <a:ext cx="47625" cy="1333500"/>
+          </a:xfrm>
+          <a:prstGeom prst="rect">
+            <a:avLst/>
+          </a:prstGeom>
+          <a:solidFill>
+            <a:srgbClr val="4E79A7"/>
+          </a:solidFill>
+          <a:ln w="12700">
+            <a:solidFill>
+              <a:srgbClr val="4E79A7"/>
+            </a:solidFill>
+            <a:prstDash val="solid"/>
+          </a:ln>
+        </p:spPr>
+      </p:sp>
+      <p:sp>
+        <p:nvSpPr>
+          <p:cNvPr id="24" name="Text 21"/>
+          <p:cNvSpPr/>
+          <p:nvPr/>
+        </p:nvSpPr>
+        <p:spPr>
+          <a:xfrm>
+            <a:off x="6305550" y="3581400"/>
+            <a:ext cx="1562100" cy="1143000"/>
+          </a:xfrm>
+          <a:prstGeom prst="rect">
+            <a:avLst/>
+          </a:prstGeom>
+          <a:noFill/>
+          <a:ln/>
+        </p:spPr>
+        <p:txBody>
+          <a:bodyPr wrap="square" lIns="0" tIns="0" rIns="0" bIns="0" rtlCol="0" anchor="ctr"/>
+          <a:lstStyle/>
+          <a:p>
+            <a:pPr algn="l" indent="0" marL="0">
+              <a:buNone/>
+            </a:pPr>
+            <a:r>
+              <a:rPr lang="en-US" sz="1300" dirty="0">
+                <a:solidFill>
+                  <a:srgbClr val="6C6C8A"/>
+                </a:solidFill>
+                <a:latin typeface="Helvetica Neue" pitchFamily="34" charset="0"/>
+                <a:ea typeface="Helvetica Neue" pitchFamily="34" charset="-122"/>
+                <a:cs typeface="Helvetica Neue" pitchFamily="34" charset="-120"/>
+              </a:rPr>
+              <a:t>Frame</a:t>
+            </a:r>
+            <a:endParaRPr lang="en-US" sz="1300" dirty="0"/>
+          </a:p>
+        </p:txBody>
+      </p:sp>
+      <p:sp>
+        <p:nvSpPr>
+          <p:cNvPr id="25" name="Shape 22"/>
+          <p:cNvSpPr/>
+          <p:nvPr/>
+        </p:nvSpPr>
+        <p:spPr>
+          <a:xfrm>
+            <a:off x="8077200" y="2533650"/>
+            <a:ext cx="1790700" cy="800100"/>
+          </a:xfrm>
+          <a:prstGeom prst="chevron">
+            <a:avLst/>
+          </a:prstGeom>
+          <a:solidFill>
+            <a:srgbClr val="F28E2B"/>
+          </a:solidFill>
+          <a:ln w="12700">
+            <a:solidFill>
+              <a:srgbClr val="F28E2B"/>
+            </a:solidFill>
+            <a:prstDash val="solid"/>
+          </a:ln>
+        </p:spPr>
+      </p:sp>
+      <p:sp>
+        <p:nvSpPr>
+          <p:cNvPr id="26" name="Text 23"/>
+          <p:cNvSpPr/>
+          <p:nvPr/>
+        </p:nvSpPr>
+        <p:spPr>
+          <a:xfrm>
+            <a:off x="8343900" y="2533650"/>
+            <a:ext cx="1104900" cy="800100"/>
+          </a:xfrm>
+          <a:prstGeom prst="rect">
+            <a:avLst/>
+          </a:prstGeom>
+          <a:noFill/>
+          <a:ln/>
+        </p:spPr>
+        <p:txBody>
+          <a:bodyPr wrap="square" lIns="0" tIns="0" rIns="0" bIns="0" rtlCol="0" anchor="ctr"/>
+          <a:lstStyle/>
+          <a:p>
+            <a:pPr algn="ctr" indent="0" marL="0">
+              <a:buNone/>
+            </a:pPr>
+            <a:r>
+              <a:rPr lang="en-US" sz="1400" b="1" dirty="0">
+                <a:solidFill>
+                  <a:srgbClr val="FFFFFF"/>
+                </a:solidFill>
+                <a:latin typeface="Helvetica Neue" pitchFamily="34" charset="0"/>
+                <a:ea typeface="Helvetica Neue" pitchFamily="34" charset="-122"/>
+                <a:cs typeface="Helvetica Neue" pitchFamily="34" charset="-120"/>
+              </a:rPr>
+              <a:t>Prove</a:t>
+            </a:r>
+            <a:endParaRPr lang="en-US" sz="1400" dirty="0"/>
+          </a:p>
+        </p:txBody>
+      </p:sp>
+      <p:sp>
+        <p:nvSpPr>
+          <p:cNvPr id="27" name="Shape 24"/>
+          <p:cNvSpPr/>
+          <p:nvPr/>
+        </p:nvSpPr>
+        <p:spPr>
+          <a:xfrm>
+            <a:off x="8077200" y="3486150"/>
+            <a:ext cx="1790700" cy="1333500"/>
+          </a:xfrm>
+          <a:prstGeom prst="roundRect">
+            <a:avLst>
+              <a:gd name="adj" fmla="val 6857"/>
+            </a:avLst>
+          </a:prstGeom>
+          <a:solidFill>
+            <a:srgbClr val="2B2B4A"/>
+          </a:solidFill>
+          <a:ln w="12700">
+            <a:solidFill>
+              <a:srgbClr val="2B2B4A"/>
+            </a:solidFill>
+            <a:prstDash val="solid"/>
+          </a:ln>
+        </p:spPr>
+      </p:sp>
+      <p:sp>
+        <p:nvSpPr>
+          <p:cNvPr id="28" name="Shape 25"/>
+          <p:cNvSpPr/>
+          <p:nvPr/>
+        </p:nvSpPr>
+        <p:spPr>
+          <a:xfrm>
+            <a:off x="8077200" y="3486150"/>
+            <a:ext cx="47625" cy="1333500"/>
+          </a:xfrm>
+          <a:prstGeom prst="rect">
+            <a:avLst/>
+          </a:prstGeom>
+          <a:solidFill>
+            <a:srgbClr val="F28E2B"/>
+          </a:solidFill>
+          <a:ln w="12700">
+            <a:solidFill>
+              <a:srgbClr val="F28E2B"/>
+            </a:solidFill>
+            <a:prstDash val="solid"/>
+          </a:ln>
+        </p:spPr>
+      </p:sp>
+      <p:sp>
+        <p:nvSpPr>
+          <p:cNvPr id="29" name="Text 26"/>
+          <p:cNvSpPr/>
+          <p:nvPr/>
+        </p:nvSpPr>
+        <p:spPr>
+          <a:xfrm>
+            <a:off x="8210550" y="3581400"/>
+            <a:ext cx="1562100" cy="1143000"/>
+          </a:xfrm>
+          <a:prstGeom prst="rect">
+            <a:avLst/>
+          </a:prstGeom>
+          <a:noFill/>
+          <a:ln/>
+        </p:spPr>
+        <p:txBody>
+          <a:bodyPr wrap="square" lIns="0" tIns="0" rIns="0" bIns="0" rtlCol="0" anchor="ctr"/>
+          <a:lstStyle/>
+          <a:p>
+            <a:pPr algn="l" indent="0" marL="0">
+              <a:buNone/>
+            </a:pPr>
+            <a:r>
+              <a:rPr lang="en-US" sz="1300" dirty="0">
+                <a:solidFill>
+                  <a:srgbClr val="6C6C8A"/>
+                </a:solidFill>
+                <a:latin typeface="Helvetica Neue" pitchFamily="34" charset="0"/>
+                <a:ea typeface="Helvetica Neue" pitchFamily="34" charset="-122"/>
+                <a:cs typeface="Helvetica Neue" pitchFamily="34" charset="-120"/>
+              </a:rPr>
+              <a:t>Prove</a:t>
+            </a:r>
+            <a:endParaRPr lang="en-US" sz="1300" dirty="0"/>
+          </a:p>
+        </p:txBody>
+      </p:sp>
+      <p:sp>
+        <p:nvSpPr>
+          <p:cNvPr id="30" name="Shape 27"/>
+          <p:cNvSpPr/>
+          <p:nvPr/>
+        </p:nvSpPr>
+        <p:spPr>
+          <a:xfrm>
+            <a:off x="9982200" y="2533650"/>
+            <a:ext cx="1790700" cy="800100"/>
+          </a:xfrm>
+          <a:prstGeom prst="chevron">
+            <a:avLst/>
+          </a:prstGeom>
+          <a:solidFill>
+            <a:srgbClr val="E15759"/>
+          </a:solidFill>
+          <a:ln w="12700">
+            <a:solidFill>
+              <a:srgbClr val="E15759"/>
+            </a:solidFill>
+            <a:prstDash val="solid"/>
+          </a:ln>
+        </p:spPr>
+      </p:sp>
+      <p:sp>
+        <p:nvSpPr>
+          <p:cNvPr id="31" name="Text 28"/>
+          <p:cNvSpPr/>
+          <p:nvPr/>
+        </p:nvSpPr>
+        <p:spPr>
+          <a:xfrm>
+            <a:off x="10248900" y="2533650"/>
+            <a:ext cx="1104900" cy="800100"/>
+          </a:xfrm>
+          <a:prstGeom prst="rect">
+            <a:avLst/>
+          </a:prstGeom>
+          <a:noFill/>
+          <a:ln/>
+        </p:spPr>
+        <p:txBody>
+          <a:bodyPr wrap="square" lIns="0" tIns="0" rIns="0" bIns="0" rtlCol="0" anchor="ctr"/>
+          <a:lstStyle/>
+          <a:p>
+            <a:pPr algn="ctr" indent="0" marL="0">
+              <a:buNone/>
+            </a:pPr>
+            <a:r>
+              <a:rPr lang="en-US" sz="1400" b="1" dirty="0">
+                <a:solidFill>
+                  <a:srgbClr val="FFFFFF"/>
+                </a:solidFill>
+                <a:latin typeface="Helvetica Neue" pitchFamily="34" charset="0"/>
+                <a:ea typeface="Helvetica Neue" pitchFamily="34" charset="-122"/>
+                <a:cs typeface="Helvetica Neue" pitchFamily="34" charset="-120"/>
+              </a:rPr>
+              <a:t>Scale</a:t>
+            </a:r>
+            <a:endParaRPr lang="en-US" sz="1400" dirty="0"/>
+          </a:p>
+        </p:txBody>
+      </p:sp>
+      <p:sp>
+        <p:nvSpPr>
+          <p:cNvPr id="32" name="Shape 29"/>
+          <p:cNvSpPr/>
+          <p:nvPr/>
+        </p:nvSpPr>
+        <p:spPr>
+          <a:xfrm>
+            <a:off x="9982200" y="3486150"/>
+            <a:ext cx="1790700" cy="1333500"/>
+          </a:xfrm>
+          <a:prstGeom prst="roundRect">
+            <a:avLst>
+              <a:gd name="adj" fmla="val 6857"/>
+            </a:avLst>
+          </a:prstGeom>
+          <a:solidFill>
+            <a:srgbClr val="2B2B4A"/>
+          </a:solidFill>
+          <a:ln w="12700">
+            <a:solidFill>
+              <a:srgbClr val="2B2B4A"/>
+            </a:solidFill>
+            <a:prstDash val="solid"/>
+          </a:ln>
+        </p:spPr>
+      </p:sp>
+      <p:sp>
+        <p:nvSpPr>
+          <p:cNvPr id="33" name="Shape 30"/>
+          <p:cNvSpPr/>
+          <p:nvPr/>
+        </p:nvSpPr>
+        <p:spPr>
+          <a:xfrm>
+            <a:off x="9982200" y="3486150"/>
+            <a:ext cx="47625" cy="1333500"/>
+          </a:xfrm>
+          <a:prstGeom prst="rect">
+            <a:avLst/>
+          </a:prstGeom>
+          <a:solidFill>
+            <a:srgbClr val="E15759"/>
+          </a:solidFill>
+          <a:ln w="12700">
+            <a:solidFill>
+              <a:srgbClr val="E15759"/>
+            </a:solidFill>
+            <a:prstDash val="solid"/>
+          </a:ln>
+        </p:spPr>
+      </p:sp>
+      <p:sp>
+        <p:nvSpPr>
+          <p:cNvPr id="34" name="Text 31"/>
+          <p:cNvSpPr/>
+          <p:nvPr/>
+        </p:nvSpPr>
+        <p:spPr>
+          <a:xfrm>
+            <a:off x="10115550" y="3581400"/>
+            <a:ext cx="1562100" cy="1143000"/>
+          </a:xfrm>
+          <a:prstGeom prst="rect">
+            <a:avLst/>
+          </a:prstGeom>
+          <a:noFill/>
+          <a:ln/>
+        </p:spPr>
+        <p:txBody>
+          <a:bodyPr wrap="square" lIns="0" tIns="0" rIns="0" bIns="0" rtlCol="0" anchor="ctr"/>
+          <a:lstStyle/>
+          <a:p>
+            <a:pPr algn="l" indent="0" marL="0">
+              <a:buNone/>
+            </a:pPr>
+            <a:r>
+              <a:rPr lang="en-US" sz="1300" dirty="0">
+                <a:solidFill>
+                  <a:srgbClr val="6C6C8A"/>
+                </a:solidFill>
+                <a:latin typeface="Helvetica Neue" pitchFamily="34" charset="0"/>
+                <a:ea typeface="Helvetica Neue" pitchFamily="34" charset="-122"/>
+                <a:cs typeface="Helvetica Neue" pitchFamily="34" charset="-120"/>
+              </a:rPr>
+              <a:t>Scale</a:t>
+            </a:r>
+            <a:endParaRPr lang="en-US" sz="1300" dirty="0"/>
+          </a:p>
+        </p:txBody>
+      </p:sp>
+    </p:spTree>
+  </p:cSld>
+  <p:clrMapOvr>
+    <a:masterClrMapping/>
+  </p:clrMapOvr>
+</p:sld>
+</file>
+
+<file path=ppt/slides/slide13.xml><?xml version="1.0" encoding="utf-8"?>
+<p:sld xmlns:a="http://schemas.openxmlformats.org/drawingml/2006/main" xmlns:r="http://schemas.openxmlformats.org/officeDocument/2006/relationships" xmlns:p="http://schemas.openxmlformats.org/presentationml/2006/main">
+  <p:cSld name="Slide 13">
+    <p:bg>
+      <p:bgPr>
+        <a:solidFill>
+          <a:srgbClr val="1A1A2E"/>
+        </a:solidFill>
+      </p:bgPr>
+    </p:bg>
+    <p:spTree>
+      <p:nvGrpSpPr>
+        <p:cNvPr id="1" name=""/>
+        <p:cNvGrpSpPr/>
+        <p:nvPr/>
+      </p:nvGrpSpPr>
+      <p:grpSpPr>
+        <a:xfrm>
+          <a:off x="0" y="0"/>
+          <a:ext cx="0" cy="0"/>
+          <a:chOff x="0" y="0"/>
+          <a:chExt cx="0" cy="0"/>
+        </a:xfrm>
+      </p:grpSpPr>
+      <p:pic>
+        <p:nvPicPr>
+          <p:cNvPr id="2" name="Image 0" descr="/Users/dpadmana/projects/ppt-gen/assets/brand/logo.svg">    </p:cNvPr>
+          <p:cNvPicPr>
+            <a:picLocks noChangeAspect="1"/>
+          </p:cNvPicPr>
+          <p:nvPr/>
+        </p:nvPicPr>
+        <p:blipFill>
+          <a:blip r:embed="rId1">
+            <a:extLst>
+              <a:ext uri="{96DAC541-7B7A-43D3-8B79-37D633B846F1}">
+                <asvg:svgBlip xmlns:asvg="http://schemas.microsoft.com/office/drawing/2016/SVG/main" r:embed="rId2"/>
+              </a:ext>
+            </a:extLst>
+          </a:blip>
+          <a:stretch>
+            <a:fillRect/>
+          </a:stretch>
+        </p:blipFill>
+        <p:spPr>
+          <a:xfrm>
+            <a:off x="11468100" y="266700"/>
+            <a:ext cx="381000" cy="381000"/>
+          </a:xfrm>
+          <a:prstGeom prst="rect">
+            <a:avLst/>
+          </a:prstGeom>
+        </p:spPr>
+      </p:pic>
+      <p:sp>
+        <p:nvSpPr>
+          <p:cNvPr id="3" name="Text 0"/>
+          <p:cNvSpPr/>
+          <p:nvPr/>
+        </p:nvSpPr>
+        <p:spPr>
+          <a:xfrm>
+            <a:off x="400050" y="247650"/>
+            <a:ext cx="10877550" cy="381000"/>
+          </a:xfrm>
+          <a:prstGeom prst="rect">
+            <a:avLst/>
+          </a:prstGeom>
+          <a:noFill/>
+          <a:ln/>
+        </p:spPr>
+        <p:txBody>
+          <a:bodyPr wrap="square" lIns="0" tIns="0" rIns="0" bIns="0" rtlCol="0" anchor="t"/>
+          <a:lstStyle/>
+          <a:p>
+            <a:pPr algn="l" indent="0" marL="0">
+              <a:buNone/>
+            </a:pPr>
+            <a:r>
+              <a:rPr lang="en-US" sz="3000" b="1" dirty="0">
+                <a:solidFill>
+                  <a:srgbClr val="EAEAEA"/>
+                </a:solidFill>
+                <a:latin typeface="Helvetica Neue" pitchFamily="34" charset="0"/>
+                <a:ea typeface="Helvetica Neue" pitchFamily="34" charset="-122"/>
+                <a:cs typeface="Helvetica Neue" pitchFamily="34" charset="-120"/>
+              </a:rPr>
+              <a:t>Compose — stacked (rows)</a:t>
+            </a:r>
+            <a:endParaRPr lang="en-US" sz="3000" dirty="0"/>
+          </a:p>
+        </p:txBody>
+      </p:sp>
+      <p:sp>
+        <p:nvSpPr>
+          <p:cNvPr id="4" name="Text 1"/>
+          <p:cNvSpPr/>
+          <p:nvPr/>
+        </p:nvSpPr>
+        <p:spPr>
+          <a:xfrm>
+            <a:off x="400050" y="6457950"/>
+            <a:ext cx="4953000" cy="171450"/>
+          </a:xfrm>
+          <a:prstGeom prst="rect">
+            <a:avLst/>
+          </a:prstGeom>
+          <a:noFill/>
+          <a:ln/>
+        </p:spPr>
+        <p:txBody>
+          <a:bodyPr wrap="square" lIns="0" tIns="0" rIns="0" bIns="0" rtlCol="0" anchor="t"/>
+          <a:lstStyle/>
+          <a:p>
+            <a:pPr algn="l" indent="0" marL="0">
+              <a:buNone/>
+            </a:pPr>
+            <a:r>
+              <a:rPr lang="en-US" sz="1100" b="1" dirty="0">
+                <a:solidFill>
+                  <a:srgbClr val="6C6C8A"/>
+                </a:solidFill>
+                <a:latin typeface="Helvetica Neue" pitchFamily="34" charset="0"/>
+                <a:ea typeface="Helvetica Neue" pitchFamily="34" charset="-122"/>
+                <a:cs typeface="Helvetica Neue" pitchFamily="34" charset="-120"/>
+              </a:rPr>
+              <a:t>PPT-GEN  ·  TEMPLATE GALLERY</a:t>
+            </a:r>
+            <a:endParaRPr lang="en-US" sz="1100" dirty="0"/>
+          </a:p>
+        </p:txBody>
+      </p:sp>
+      <p:sp>
+        <p:nvSpPr>
+          <p:cNvPr id="5" name="Shape 2"/>
+          <p:cNvSpPr/>
+          <p:nvPr/>
+        </p:nvSpPr>
+        <p:spPr>
+          <a:xfrm>
+            <a:off x="5405438" y="6438900"/>
+            <a:ext cx="1381125" cy="209550"/>
+          </a:xfrm>
+          <a:prstGeom prst="roundRect">
+            <a:avLst>
+              <a:gd name="adj" fmla="val 43636"/>
+            </a:avLst>
+          </a:prstGeom>
+          <a:solidFill>
+            <a:srgbClr val="E94560"/>
+          </a:solidFill>
+          <a:ln w="12700">
+            <a:solidFill>
+              <a:srgbClr val="E94560"/>
+            </a:solidFill>
+            <a:prstDash val="solid"/>
+          </a:ln>
+        </p:spPr>
+      </p:sp>
+      <p:sp>
+        <p:nvSpPr>
+          <p:cNvPr id="6" name="Text 3"/>
+          <p:cNvSpPr/>
+          <p:nvPr/>
+        </p:nvSpPr>
+        <p:spPr>
+          <a:xfrm>
+            <a:off x="5405438" y="6457950"/>
+            <a:ext cx="1381125" cy="171450"/>
+          </a:xfrm>
+          <a:prstGeom prst="rect">
+            <a:avLst/>
+          </a:prstGeom>
+          <a:noFill/>
+          <a:ln/>
+        </p:spPr>
+        <p:txBody>
+          <a:bodyPr wrap="square" lIns="0" tIns="0" rIns="0" bIns="0" rtlCol="0" anchor="t"/>
+          <a:lstStyle/>
+          <a:p>
+            <a:pPr algn="ctr" indent="0" marL="0">
+              <a:buNone/>
+            </a:pPr>
+            <a:r>
+              <a:rPr lang="en-US" sz="1000" b="1" dirty="0">
+                <a:solidFill>
+                  <a:srgbClr val="FFFFFF"/>
+                </a:solidFill>
+                <a:latin typeface="Helvetica Neue" pitchFamily="34" charset="0"/>
+                <a:ea typeface="Helvetica Neue" pitchFamily="34" charset="-122"/>
+                <a:cs typeface="Helvetica Neue" pitchFamily="34" charset="-120"/>
+              </a:rPr>
+              <a:t>INTERNAL ONLY</a:t>
+            </a:r>
+            <a:endParaRPr lang="en-US" sz="1000" dirty="0"/>
+          </a:p>
+        </p:txBody>
+      </p:sp>
+      <p:sp>
+        <p:nvSpPr>
+          <p:cNvPr id="7" name="Text 4"/>
+          <p:cNvSpPr/>
+          <p:nvPr/>
+        </p:nvSpPr>
+        <p:spPr>
+          <a:xfrm>
+            <a:off x="11334750" y="6457950"/>
+            <a:ext cx="457200" cy="171450"/>
+          </a:xfrm>
+          <a:prstGeom prst="rect">
+            <a:avLst/>
+          </a:prstGeom>
+          <a:noFill/>
+          <a:ln/>
+        </p:spPr>
+        <p:txBody>
+          <a:bodyPr wrap="square" lIns="0" tIns="0" rIns="0" bIns="0" rtlCol="0" anchor="t"/>
+          <a:lstStyle/>
+          <a:p>
+            <a:pPr algn="r" indent="0" marL="0">
+              <a:buNone/>
+            </a:pPr>
+            <a:r>
+              <a:rPr lang="en-US" sz="1200" dirty="0">
+                <a:solidFill>
+                  <a:srgbClr val="6C6C8A"/>
+                </a:solidFill>
+                <a:latin typeface="Helvetica Neue" pitchFamily="34" charset="0"/>
+                <a:ea typeface="Helvetica Neue" pitchFamily="34" charset="-122"/>
+                <a:cs typeface="Helvetica Neue" pitchFamily="34" charset="-120"/>
+              </a:rPr>
+              <a:t>13</a:t>
+            </a:r>
+            <a:endParaRPr lang="en-US" sz="1200" dirty="0"/>
+          </a:p>
+        </p:txBody>
+      </p:sp>
+      <p:sp>
+        <p:nvSpPr>
+          <p:cNvPr id="8" name="Text 5"/>
+          <p:cNvSpPr/>
+          <p:nvPr/>
+        </p:nvSpPr>
+        <p:spPr>
+          <a:xfrm>
+            <a:off x="400050" y="819150"/>
+            <a:ext cx="11391900" cy="171450"/>
+          </a:xfrm>
+          <a:prstGeom prst="rect">
+            <a:avLst/>
+          </a:prstGeom>
+          <a:noFill/>
+          <a:ln/>
+        </p:spPr>
+        <p:txBody>
+          <a:bodyPr wrap="square" lIns="0" tIns="0" rIns="0" bIns="0" rtlCol="0" anchor="t"/>
+          <a:lstStyle/>
+          <a:p>
+            <a:pPr algn="l" indent="0" marL="0">
+              <a:buNone/>
+            </a:pPr>
+            <a:r>
+              <a:rPr lang="en-US" sz="1100" b="1" dirty="0">
+                <a:solidFill>
+                  <a:srgbClr val="6C6C8A"/>
+                </a:solidFill>
+                <a:latin typeface="Helvetica Neue" pitchFamily="34" charset="0"/>
+                <a:ea typeface="Helvetica Neue" pitchFamily="34" charset="-122"/>
+                <a:cs typeface="Helvetica Neue" pitchFamily="34" charset="-120"/>
+              </a:rPr>
+              <a:t>PORTFOLIO</a:t>
+            </a:r>
+            <a:endParaRPr lang="en-US" sz="1100" dirty="0"/>
+          </a:p>
+        </p:txBody>
+      </p:sp>
+      <p:sp>
+        <p:nvSpPr>
+          <p:cNvPr id="9" name="Shape 6"/>
+          <p:cNvSpPr/>
+          <p:nvPr/>
+        </p:nvSpPr>
+        <p:spPr>
+          <a:xfrm>
+            <a:off x="1543050" y="1143000"/>
+            <a:ext cx="4933950" cy="904875"/>
+          </a:xfrm>
+          <a:prstGeom prst="roundRect">
+            <a:avLst>
+              <a:gd name="adj" fmla="val 10105"/>
+            </a:avLst>
+          </a:prstGeom>
+          <a:solidFill>
+            <a:srgbClr val="2B2B4A"/>
+          </a:solidFill>
+          <a:ln w="15875">
+            <a:solidFill>
+              <a:srgbClr val="3A3A5C"/>
+            </a:solidFill>
+            <a:prstDash val="solid"/>
+          </a:ln>
+        </p:spPr>
+      </p:sp>
+      <p:sp>
+        <p:nvSpPr>
+          <p:cNvPr id="10" name="Shape 7"/>
+          <p:cNvSpPr/>
+          <p:nvPr/>
+        </p:nvSpPr>
+        <p:spPr>
+          <a:xfrm>
+            <a:off x="6572250" y="1143000"/>
+            <a:ext cx="4933950" cy="904875"/>
+          </a:xfrm>
+          <a:prstGeom prst="roundRect">
+            <a:avLst>
+              <a:gd name="adj" fmla="val 10105"/>
+            </a:avLst>
+          </a:prstGeom>
+          <a:solidFill>
+            <a:srgbClr val="2B2B4A"/>
+          </a:solidFill>
+          <a:ln w="15875">
+            <a:solidFill>
+              <a:srgbClr val="3A3A5C"/>
+            </a:solidFill>
+            <a:prstDash val="solid"/>
+          </a:ln>
+        </p:spPr>
+      </p:sp>
+      <p:sp>
+        <p:nvSpPr>
+          <p:cNvPr id="11" name="Shape 8"/>
+          <p:cNvSpPr/>
+          <p:nvPr/>
+        </p:nvSpPr>
+        <p:spPr>
+          <a:xfrm>
+            <a:off x="1543050" y="2143125"/>
+            <a:ext cx="4933950" cy="904875"/>
+          </a:xfrm>
+          <a:prstGeom prst="roundRect">
+            <a:avLst>
+              <a:gd name="adj" fmla="val 10105"/>
+            </a:avLst>
+          </a:prstGeom>
+          <a:solidFill>
+            <a:srgbClr val="2B2B4A"/>
+          </a:solidFill>
+          <a:ln w="15875">
+            <a:solidFill>
+              <a:srgbClr val="3A3A5C"/>
+            </a:solidFill>
+            <a:prstDash val="solid"/>
+          </a:ln>
+        </p:spPr>
+      </p:sp>
+      <p:sp>
+        <p:nvSpPr>
+          <p:cNvPr id="12" name="Shape 9"/>
+          <p:cNvSpPr/>
+          <p:nvPr/>
+        </p:nvSpPr>
+        <p:spPr>
+          <a:xfrm>
+            <a:off x="6572250" y="2143125"/>
+            <a:ext cx="4933950" cy="904875"/>
+          </a:xfrm>
+          <a:prstGeom prst="roundRect">
+            <a:avLst>
+              <a:gd name="adj" fmla="val 10105"/>
+            </a:avLst>
+          </a:prstGeom>
+          <a:solidFill>
+            <a:srgbClr val="2B2B4A"/>
+          </a:solidFill>
+          <a:ln w="15875">
+            <a:solidFill>
+              <a:srgbClr val="3A3A5C"/>
+            </a:solidFill>
+            <a:prstDash val="solid"/>
+          </a:ln>
+        </p:spPr>
+      </p:sp>
+      <p:sp>
+        <p:nvSpPr>
+          <p:cNvPr id="13" name="Text 10"/>
+          <p:cNvSpPr/>
+          <p:nvPr/>
+        </p:nvSpPr>
+        <p:spPr>
+          <a:xfrm>
+            <a:off x="400050" y="1143000"/>
+            <a:ext cx="1047750" cy="266700"/>
+          </a:xfrm>
+          <a:prstGeom prst="rect">
+            <a:avLst/>
+          </a:prstGeom>
+          <a:noFill/>
+          <a:ln/>
+        </p:spPr>
+        <p:txBody>
+          <a:bodyPr wrap="square" lIns="0" tIns="0" rIns="0" bIns="0" rtlCol="0" anchor="t"/>
+          <a:lstStyle/>
+          <a:p>
+            <a:pPr algn="l" indent="0" marL="0">
+              <a:buNone/>
+            </a:pPr>
+            <a:r>
+              <a:rPr lang="en-US" sz="1400" b="1" dirty="0">
+                <a:solidFill>
+                  <a:srgbClr val="6C6C8A"/>
+                </a:solidFill>
+                <a:latin typeface="Helvetica Neue" pitchFamily="34" charset="0"/>
+                <a:ea typeface="Helvetica Neue" pitchFamily="34" charset="-122"/>
+                <a:cs typeface="Helvetica Neue" pitchFamily="34" charset="-120"/>
+              </a:rPr>
+              <a:t>Impact</a:t>
+            </a:r>
+            <a:endParaRPr lang="en-US" sz="1400" dirty="0"/>
+          </a:p>
+        </p:txBody>
+      </p:sp>
+      <p:sp>
+        <p:nvSpPr>
+          <p:cNvPr id="14" name="Text 11"/>
+          <p:cNvSpPr/>
+          <p:nvPr/>
+        </p:nvSpPr>
+        <p:spPr>
+          <a:xfrm>
+            <a:off x="1543050" y="3200400"/>
+            <a:ext cx="9963150" cy="266700"/>
+          </a:xfrm>
+          <a:prstGeom prst="rect">
+            <a:avLst/>
+          </a:prstGeom>
+          <a:noFill/>
+          <a:ln/>
+        </p:spPr>
+        <p:txBody>
+          <a:bodyPr wrap="square" lIns="0" tIns="0" rIns="0" bIns="0" rtlCol="0" anchor="t"/>
+          <a:lstStyle/>
+          <a:p>
+            <a:pPr algn="ctr" indent="0" marL="0">
+              <a:buNone/>
+            </a:pPr>
+            <a:r>
+              <a:rPr lang="en-US" sz="1400" b="1" dirty="0">
+                <a:solidFill>
+                  <a:srgbClr val="6C6C8A"/>
+                </a:solidFill>
+                <a:latin typeface="Helvetica Neue" pitchFamily="34" charset="0"/>
+                <a:ea typeface="Helvetica Neue" pitchFamily="34" charset="-122"/>
+                <a:cs typeface="Helvetica Neue" pitchFamily="34" charset="-120"/>
+              </a:rPr>
+              <a:t>Ease</a:t>
+            </a:r>
+            <a:endParaRPr lang="en-US" sz="1400" dirty="0"/>
+          </a:p>
+        </p:txBody>
+      </p:sp>
+      <p:sp>
+        <p:nvSpPr>
+          <p:cNvPr id="15" name="Shape 12"/>
+          <p:cNvSpPr/>
+          <p:nvPr/>
+        </p:nvSpPr>
+        <p:spPr>
+          <a:xfrm>
+            <a:off x="1695450" y="1314450"/>
+            <a:ext cx="4629150" cy="381000"/>
+          </a:xfrm>
+          <a:prstGeom prst="roundRect">
+            <a:avLst>
+              <a:gd name="adj" fmla="val 24000"/>
+            </a:avLst>
+          </a:prstGeom>
+          <a:solidFill>
+            <a:srgbClr val="1F1F36"/>
+          </a:solidFill>
+          <a:ln w="15875">
+            <a:solidFill>
+              <a:srgbClr val="4E79A7"/>
+            </a:solidFill>
+            <a:prstDash val="solid"/>
+          </a:ln>
+        </p:spPr>
+      </p:sp>
+      <p:sp>
+        <p:nvSpPr>
+          <p:cNvPr id="16" name="Text 13"/>
+          <p:cNvSpPr/>
+          <p:nvPr/>
+        </p:nvSpPr>
+        <p:spPr>
+          <a:xfrm>
+            <a:off x="1809750" y="1314450"/>
+            <a:ext cx="4400550" cy="381000"/>
+          </a:xfrm>
+          <a:prstGeom prst="rect">
+            <a:avLst/>
+          </a:prstGeom>
+          <a:noFill/>
+          <a:ln/>
+        </p:spPr>
+        <p:txBody>
+          <a:bodyPr wrap="square" lIns="0" tIns="0" rIns="0" bIns="0" rtlCol="0" anchor="ctr"/>
+          <a:lstStyle/>
+          <a:p>
+            <a:pPr algn="l" indent="0" marL="0">
+              <a:buNone/>
+            </a:pPr>
+            <a:r>
+              <a:rPr lang="en-US" sz="1600" b="1" dirty="0">
+                <a:solidFill>
+                  <a:srgbClr val="EAEAEA"/>
+                </a:solidFill>
+                <a:latin typeface="Helvetica Neue" pitchFamily="34" charset="0"/>
+                <a:ea typeface="Helvetica Neue" pitchFamily="34" charset="-122"/>
+                <a:cs typeface="Helvetica Neue" pitchFamily="34" charset="-120"/>
+              </a:rPr>
+              <a:t>Rewrite</a:t>
+            </a:r>
+            <a:endParaRPr lang="en-US" sz="1600" dirty="0"/>
+          </a:p>
+        </p:txBody>
+      </p:sp>
+      <p:sp>
+        <p:nvSpPr>
+          <p:cNvPr id="17" name="Shape 14"/>
+          <p:cNvSpPr/>
+          <p:nvPr/>
+        </p:nvSpPr>
+        <p:spPr>
+          <a:xfrm>
+            <a:off x="6724650" y="1314450"/>
+            <a:ext cx="4629150" cy="381000"/>
+          </a:xfrm>
+          <a:prstGeom prst="roundRect">
+            <a:avLst>
+              <a:gd name="adj" fmla="val 24000"/>
+            </a:avLst>
+          </a:prstGeom>
+          <a:solidFill>
+            <a:srgbClr val="1F1F36"/>
+          </a:solidFill>
+          <a:ln w="15875">
+            <a:solidFill>
+              <a:srgbClr val="4E79A7"/>
+            </a:solidFill>
+            <a:prstDash val="solid"/>
+          </a:ln>
+        </p:spPr>
+      </p:sp>
+      <p:sp>
+        <p:nvSpPr>
+          <p:cNvPr id="18" name="Text 15"/>
+          <p:cNvSpPr/>
+          <p:nvPr/>
+        </p:nvSpPr>
+        <p:spPr>
+          <a:xfrm>
+            <a:off x="6838950" y="1314450"/>
+            <a:ext cx="4400550" cy="381000"/>
+          </a:xfrm>
+          <a:prstGeom prst="rect">
+            <a:avLst/>
+          </a:prstGeom>
+          <a:noFill/>
+          <a:ln/>
+        </p:spPr>
+        <p:txBody>
+          <a:bodyPr wrap="square" lIns="0" tIns="0" rIns="0" bIns="0" rtlCol="0" anchor="ctr"/>
+          <a:lstStyle/>
+          <a:p>
+            <a:pPr algn="l" indent="0" marL="0">
+              <a:buNone/>
+            </a:pPr>
+            <a:r>
+              <a:rPr lang="en-US" sz="1600" b="1" dirty="0">
+                <a:solidFill>
+                  <a:srgbClr val="EAEAEA"/>
+                </a:solidFill>
+                <a:latin typeface="Helvetica Neue" pitchFamily="34" charset="0"/>
+                <a:ea typeface="Helvetica Neue" pitchFamily="34" charset="-122"/>
+                <a:cs typeface="Helvetica Neue" pitchFamily="34" charset="-120"/>
+              </a:rPr>
+              <a:t>Onboarding</a:t>
+            </a:r>
+            <a:endParaRPr lang="en-US" sz="1600" dirty="0"/>
+          </a:p>
+        </p:txBody>
+      </p:sp>
+      <p:sp>
+        <p:nvSpPr>
+          <p:cNvPr id="19" name="Text 16"/>
+          <p:cNvSpPr/>
+          <p:nvPr/>
+        </p:nvSpPr>
+        <p:spPr>
+          <a:xfrm>
+            <a:off x="400050" y="3543300"/>
+            <a:ext cx="11391900" cy="171450"/>
+          </a:xfrm>
+          <a:prstGeom prst="rect">
+            <a:avLst/>
+          </a:prstGeom>
+          <a:noFill/>
+          <a:ln/>
+        </p:spPr>
+        <p:txBody>
+          <a:bodyPr wrap="square" lIns="0" tIns="0" rIns="0" bIns="0" rtlCol="0" anchor="t"/>
+          <a:lstStyle/>
+          <a:p>
+            <a:pPr algn="l" indent="0" marL="0">
+              <a:buNone/>
+            </a:pPr>
+            <a:r>
+              <a:rPr lang="en-US" sz="1100" b="1" dirty="0">
+                <a:solidFill>
+                  <a:srgbClr val="6C6C8A"/>
+                </a:solidFill>
+                <a:latin typeface="Helvetica Neue" pitchFamily="34" charset="0"/>
+                <a:ea typeface="Helvetica Neue" pitchFamily="34" charset="-122"/>
+                <a:cs typeface="Helvetica Neue" pitchFamily="34" charset="-120"/>
+              </a:rPr>
+              <a:t>OWNERS</a:t>
+            </a:r>
+            <a:endParaRPr lang="en-US" sz="1100" dirty="0"/>
+          </a:p>
+        </p:txBody>
+      </p:sp>
+      <p:sp>
+        <p:nvSpPr>
+          <p:cNvPr id="20" name="Text 17"/>
+          <p:cNvSpPr/>
+          <p:nvPr/>
+        </p:nvSpPr>
+        <p:spPr>
+          <a:xfrm>
+            <a:off x="3143250" y="4210050"/>
+            <a:ext cx="4210050" cy="266700"/>
+          </a:xfrm>
+          <a:prstGeom prst="rect">
+            <a:avLst/>
+          </a:prstGeom>
+          <a:noFill/>
+          <a:ln/>
+        </p:spPr>
+        <p:txBody>
+          <a:bodyPr wrap="square" lIns="0" tIns="0" rIns="0" bIns="0" rtlCol="0" anchor="ctr"/>
+          <a:lstStyle/>
+          <a:p>
+            <a:pPr algn="ctr" indent="0" marL="0">
+              <a:buNone/>
+            </a:pPr>
+            <a:r>
+              <a:rPr lang="en-US" sz="1100" b="1" dirty="0">
+                <a:solidFill>
+                  <a:srgbClr val="6C6C8A"/>
+                </a:solidFill>
+                <a:latin typeface="Helvetica Neue" pitchFamily="34" charset="0"/>
+                <a:ea typeface="Helvetica Neue" pitchFamily="34" charset="-122"/>
+                <a:cs typeface="Helvetica Neue" pitchFamily="34" charset="-120"/>
+              </a:rPr>
+              <a:t>PM</a:t>
+            </a:r>
+            <a:endParaRPr lang="en-US" sz="1100" dirty="0"/>
+          </a:p>
+        </p:txBody>
+      </p:sp>
+      <p:sp>
+        <p:nvSpPr>
+          <p:cNvPr id="21" name="Text 18"/>
+          <p:cNvSpPr/>
+          <p:nvPr/>
+        </p:nvSpPr>
+        <p:spPr>
+          <a:xfrm>
+            <a:off x="7505700" y="4210050"/>
+            <a:ext cx="4210050" cy="266700"/>
+          </a:xfrm>
+          <a:prstGeom prst="rect">
+            <a:avLst/>
+          </a:prstGeom>
+          <a:noFill/>
+          <a:ln/>
+        </p:spPr>
+        <p:txBody>
+          <a:bodyPr wrap="square" lIns="0" tIns="0" rIns="0" bIns="0" rtlCol="0" anchor="ctr"/>
+          <a:lstStyle/>
+          <a:p>
+            <a:pPr algn="ctr" indent="0" marL="0">
+              <a:buNone/>
+            </a:pPr>
+            <a:r>
+              <a:rPr lang="en-US" sz="1100" b="1" dirty="0">
+                <a:solidFill>
+                  <a:srgbClr val="6C6C8A"/>
+                </a:solidFill>
+                <a:latin typeface="Helvetica Neue" pitchFamily="34" charset="0"/>
+                <a:ea typeface="Helvetica Neue" pitchFamily="34" charset="-122"/>
+                <a:cs typeface="Helvetica Neue" pitchFamily="34" charset="-120"/>
+              </a:rPr>
+              <a:t>ENG</a:t>
+            </a:r>
+            <a:endParaRPr lang="en-US" sz="1100" dirty="0"/>
+          </a:p>
+        </p:txBody>
+      </p:sp>
+      <p:sp>
+        <p:nvSpPr>
+          <p:cNvPr id="22" name="Shape 19"/>
+          <p:cNvSpPr/>
+          <p:nvPr/>
+        </p:nvSpPr>
+        <p:spPr>
+          <a:xfrm>
+            <a:off x="400050" y="4572000"/>
+            <a:ext cx="11391900" cy="438150"/>
+          </a:xfrm>
+          <a:prstGeom prst="rect">
+            <a:avLst/>
+          </a:prstGeom>
+          <a:solidFill>
+            <a:srgbClr val="2B2B4A"/>
+          </a:solidFill>
+          <a:ln w="15875">
+            <a:solidFill>
+              <a:srgbClr val="3A3A5C"/>
+            </a:solidFill>
+            <a:prstDash val="solid"/>
+          </a:ln>
+        </p:spPr>
+      </p:sp>
+      <p:sp>
+        <p:nvSpPr>
+          <p:cNvPr id="23" name="Text 20"/>
+          <p:cNvSpPr/>
+          <p:nvPr/>
+        </p:nvSpPr>
+        <p:spPr>
+          <a:xfrm>
+            <a:off x="533400" y="4572000"/>
+            <a:ext cx="2438400" cy="438150"/>
+          </a:xfrm>
+          <a:prstGeom prst="rect">
+            <a:avLst/>
+          </a:prstGeom>
+          <a:noFill/>
+          <a:ln/>
+        </p:spPr>
+        <p:txBody>
+          <a:bodyPr wrap="square" lIns="0" tIns="0" rIns="0" bIns="0" rtlCol="0" anchor="ctr"/>
+          <a:lstStyle/>
+          <a:p>
+            <a:pPr algn="l" indent="0" marL="0">
+              <a:buNone/>
+            </a:pPr>
+            <a:r>
+              <a:rPr lang="en-US" sz="1300" b="1" dirty="0">
+                <a:solidFill>
+                  <a:srgbClr val="EAEAEA"/>
+                </a:solidFill>
+                <a:latin typeface="Helvetica Neue" pitchFamily="34" charset="0"/>
+                <a:ea typeface="Helvetica Neue" pitchFamily="34" charset="-122"/>
+                <a:cs typeface="Helvetica Neue" pitchFamily="34" charset="-120"/>
+              </a:rPr>
+              <a:t>Spec</a:t>
+            </a:r>
+            <a:endParaRPr lang="en-US" sz="1300" dirty="0"/>
+          </a:p>
+        </p:txBody>
+      </p:sp>
+      <p:sp>
+        <p:nvSpPr>
+          <p:cNvPr id="24" name="Text 21"/>
+          <p:cNvSpPr/>
+          <p:nvPr/>
+        </p:nvSpPr>
+        <p:spPr>
+          <a:xfrm>
+            <a:off x="3067050" y="4572000"/>
+            <a:ext cx="4362450" cy="438150"/>
+          </a:xfrm>
+          <a:prstGeom prst="rect">
+            <a:avLst/>
+          </a:prstGeom>
+          <a:noFill/>
+          <a:ln/>
+        </p:spPr>
+        <p:txBody>
+          <a:bodyPr wrap="square" lIns="0" tIns="0" rIns="0" bIns="0" rtlCol="0" anchor="ctr"/>
+          <a:lstStyle/>
+          <a:p>
+            <a:pPr algn="ctr" indent="0" marL="0">
+              <a:buNone/>
+            </a:pPr>
+            <a:r>
+              <a:rPr lang="en-US" sz="1600" b="1" dirty="0">
+                <a:solidFill>
+                  <a:srgbClr val="E94560"/>
+                </a:solidFill>
+                <a:latin typeface="Helvetica Neue" pitchFamily="34" charset="0"/>
+                <a:ea typeface="Helvetica Neue" pitchFamily="34" charset="-122"/>
+                <a:cs typeface="Helvetica Neue" pitchFamily="34" charset="-120"/>
+              </a:rPr>
+              <a:t>A</a:t>
+            </a:r>
+            <a:endParaRPr lang="en-US" sz="1600" dirty="0"/>
+          </a:p>
+        </p:txBody>
+      </p:sp>
+      <p:sp>
+        <p:nvSpPr>
+          <p:cNvPr id="25" name="Text 22"/>
+          <p:cNvSpPr/>
+          <p:nvPr/>
+        </p:nvSpPr>
+        <p:spPr>
+          <a:xfrm>
+            <a:off x="7429500" y="4572000"/>
+            <a:ext cx="4362450" cy="438150"/>
+          </a:xfrm>
+          <a:prstGeom prst="rect">
+            <a:avLst/>
+          </a:prstGeom>
+          <a:noFill/>
+          <a:ln/>
+        </p:spPr>
+        <p:txBody>
+          <a:bodyPr wrap="square" lIns="0" tIns="0" rIns="0" bIns="0" rtlCol="0" anchor="ctr"/>
+          <a:lstStyle/>
+          <a:p>
+            <a:pPr algn="ctr" indent="0" marL="0">
+              <a:buNone/>
+            </a:pPr>
+            <a:r>
+              <a:rPr lang="en-US" sz="1600" b="1" dirty="0">
+                <a:solidFill>
+                  <a:srgbClr val="3A3A5C"/>
+                </a:solidFill>
+                <a:latin typeface="Helvetica Neue" pitchFamily="34" charset="0"/>
+                <a:ea typeface="Helvetica Neue" pitchFamily="34" charset="-122"/>
+                <a:cs typeface="Helvetica Neue" pitchFamily="34" charset="-120"/>
+              </a:rPr>
+              <a:t>·</a:t>
+            </a:r>
+            <a:endParaRPr lang="en-US" sz="1600" dirty="0"/>
+          </a:p>
+        </p:txBody>
+      </p:sp>
+      <p:sp>
+        <p:nvSpPr>
+          <p:cNvPr id="26" name="Shape 23"/>
+          <p:cNvSpPr/>
+          <p:nvPr/>
+        </p:nvSpPr>
+        <p:spPr>
+          <a:xfrm>
+            <a:off x="400050" y="5067300"/>
+            <a:ext cx="11391900" cy="438150"/>
+          </a:xfrm>
+          <a:prstGeom prst="rect">
+            <a:avLst/>
+          </a:prstGeom>
+          <a:solidFill>
+            <a:srgbClr val="1F1F36"/>
+          </a:solidFill>
+          <a:ln w="15875">
+            <a:solidFill>
+              <a:srgbClr val="3A3A5C"/>
+            </a:solidFill>
+            <a:prstDash val="solid"/>
+          </a:ln>
+        </p:spPr>
+      </p:sp>
+      <p:sp>
+        <p:nvSpPr>
+          <p:cNvPr id="27" name="Text 24"/>
+          <p:cNvSpPr/>
+          <p:nvPr/>
+        </p:nvSpPr>
+        <p:spPr>
+          <a:xfrm>
+            <a:off x="533400" y="5067300"/>
+            <a:ext cx="2438400" cy="438150"/>
+          </a:xfrm>
+          <a:prstGeom prst="rect">
+            <a:avLst/>
+          </a:prstGeom>
+          <a:noFill/>
+          <a:ln/>
+        </p:spPr>
+        <p:txBody>
+          <a:bodyPr wrap="square" lIns="0" tIns="0" rIns="0" bIns="0" rtlCol="0" anchor="ctr"/>
+          <a:lstStyle/>
+          <a:p>
+            <a:pPr algn="l" indent="0" marL="0">
+              <a:buNone/>
+            </a:pPr>
+            <a:r>
+              <a:rPr lang="en-US" sz="1300" b="1" dirty="0">
+                <a:solidFill>
+                  <a:srgbClr val="EAEAEA"/>
+                </a:solidFill>
+                <a:latin typeface="Helvetica Neue" pitchFamily="34" charset="0"/>
+                <a:ea typeface="Helvetica Neue" pitchFamily="34" charset="-122"/>
+                <a:cs typeface="Helvetica Neue" pitchFamily="34" charset="-120"/>
+              </a:rPr>
+              <a:t>Build</a:t>
+            </a:r>
+            <a:endParaRPr lang="en-US" sz="1300" dirty="0"/>
+          </a:p>
+        </p:txBody>
+      </p:sp>
+      <p:sp>
+        <p:nvSpPr>
+          <p:cNvPr id="28" name="Text 25"/>
+          <p:cNvSpPr/>
+          <p:nvPr/>
+        </p:nvSpPr>
+        <p:spPr>
+          <a:xfrm>
+            <a:off x="3067050" y="5067300"/>
+            <a:ext cx="4362450" cy="438150"/>
+          </a:xfrm>
+          <a:prstGeom prst="rect">
+            <a:avLst/>
+          </a:prstGeom>
+          <a:noFill/>
+          <a:ln/>
+        </p:spPr>
+        <p:txBody>
+          <a:bodyPr wrap="square" lIns="0" tIns="0" rIns="0" bIns="0" rtlCol="0" anchor="ctr"/>
+          <a:lstStyle/>
+          <a:p>
+            <a:pPr algn="ctr" indent="0" marL="0">
+              <a:buNone/>
+            </a:pPr>
+            <a:r>
+              <a:rPr lang="en-US" sz="1600" b="1" dirty="0">
+                <a:solidFill>
+                  <a:srgbClr val="3A3A5C"/>
+                </a:solidFill>
+                <a:latin typeface="Helvetica Neue" pitchFamily="34" charset="0"/>
+                <a:ea typeface="Helvetica Neue" pitchFamily="34" charset="-122"/>
+                <a:cs typeface="Helvetica Neue" pitchFamily="34" charset="-120"/>
+              </a:rPr>
+              <a:t>·</a:t>
+            </a:r>
+            <a:endParaRPr lang="en-US" sz="1600" dirty="0"/>
+          </a:p>
+        </p:txBody>
+      </p:sp>
+      <p:sp>
+        <p:nvSpPr>
+          <p:cNvPr id="29" name="Text 26"/>
+          <p:cNvSpPr/>
+          <p:nvPr/>
+        </p:nvSpPr>
+        <p:spPr>
+          <a:xfrm>
+            <a:off x="7429500" y="5067300"/>
+            <a:ext cx="4362450" cy="438150"/>
+          </a:xfrm>
+          <a:prstGeom prst="rect">
+            <a:avLst/>
+          </a:prstGeom>
+          <a:noFill/>
+          <a:ln/>
+        </p:spPr>
+        <p:txBody>
+          <a:bodyPr wrap="square" lIns="0" tIns="0" rIns="0" bIns="0" rtlCol="0" anchor="ctr"/>
+          <a:lstStyle/>
+          <a:p>
+            <a:pPr algn="ctr" indent="0" marL="0">
+              <a:buNone/>
+            </a:pPr>
+            <a:r>
+              <a:rPr lang="en-US" sz="1600" b="1" dirty="0">
+                <a:solidFill>
+                  <a:srgbClr val="4E79A7"/>
+                </a:solidFill>
+                <a:latin typeface="Helvetica Neue" pitchFamily="34" charset="0"/>
+                <a:ea typeface="Helvetica Neue" pitchFamily="34" charset="-122"/>
+                <a:cs typeface="Helvetica Neue" pitchFamily="34" charset="-120"/>
+              </a:rPr>
+              <a:t>R</a:t>
+            </a:r>
+            <a:endParaRPr lang="en-US" sz="1600" dirty="0"/>
+          </a:p>
+        </p:txBody>
+      </p:sp>
+      <p:sp>
+        <p:nvSpPr>
+          <p:cNvPr id="30" name="Text 27"/>
+          <p:cNvSpPr/>
+          <p:nvPr/>
+        </p:nvSpPr>
+        <p:spPr>
+          <a:xfrm>
+            <a:off x="400050" y="5657850"/>
+            <a:ext cx="11391900" cy="209550"/>
+          </a:xfrm>
+          <a:prstGeom prst="rect">
+            <a:avLst/>
+          </a:prstGeom>
+          <a:noFill/>
+          <a:ln/>
+        </p:spPr>
+        <p:txBody>
+          <a:bodyPr wrap="square" lIns="0" tIns="0" rIns="0" bIns="0" rtlCol="0" anchor="ctr"/>
+          <a:lstStyle/>
+          <a:p>
+            <a:pPr algn="l" indent="0" marL="0">
+              <a:buNone/>
+            </a:pPr>
+            <a:r>
+              <a:rPr lang="en-US" sz="1100" dirty="0">
+                <a:solidFill>
+                  <a:srgbClr val="6C6C8A"/>
+                </a:solidFill>
+                <a:latin typeface="Helvetica Neue" pitchFamily="34" charset="0"/>
+                <a:ea typeface="Helvetica Neue" pitchFamily="34" charset="-122"/>
+                <a:cs typeface="Helvetica Neue" pitchFamily="34" charset="-120"/>
+              </a:rPr>
+              <a:t>R Responsible · A Accountable · C Consulted · I Informed</a:t>
+            </a:r>
+            <a:endParaRPr lang="en-US" sz="1100" dirty="0"/>
+          </a:p>
+        </p:txBody>
+      </p:sp>
+    </p:spTree>
+  </p:cSld>
+  <p:clrMapOvr>
+    <a:masterClrMapping/>
+  </p:clrMapOvr>
+</p:sld>
+</file>
+
+<file path=ppt/slides/slide14.xml><?xml version="1.0" encoding="utf-8"?>
+<p:sld xmlns:a="http://schemas.openxmlformats.org/drawingml/2006/main" xmlns:r="http://schemas.openxmlformats.org/officeDocument/2006/relationships" xmlns:p="http://schemas.openxmlformats.org/presentationml/2006/main">
+  <p:cSld name="Slide 14">
+    <p:bg>
+      <p:bgPr>
+        <a:solidFill>
+          <a:srgbClr val="1A1A2E"/>
+        </a:solidFill>
+      </p:bgPr>
+    </p:bg>
+    <p:spTree>
+      <p:nvGrpSpPr>
+        <p:cNvPr id="1" name=""/>
+        <p:cNvGrpSpPr/>
+        <p:nvPr/>
+      </p:nvGrpSpPr>
+      <p:grpSpPr>
+        <a:xfrm>
+          <a:off x="0" y="0"/>
+          <a:ext cx="0" cy="0"/>
+          <a:chOff x="0" y="0"/>
+          <a:chExt cx="0" cy="0"/>
+        </a:xfrm>
+      </p:grpSpPr>
+      <p:pic>
+        <p:nvPicPr>
+          <p:cNvPr id="2" name="Image 0" descr="/Users/dpadmana/projects/ppt-gen/assets/brand/logo.svg">    </p:cNvPr>
+          <p:cNvPicPr>
+            <a:picLocks noChangeAspect="1"/>
+          </p:cNvPicPr>
+          <p:nvPr/>
+        </p:nvPicPr>
+        <p:blipFill>
+          <a:blip r:embed="rId1">
+            <a:extLst>
+              <a:ext uri="{96DAC541-7B7A-43D3-8B79-37D633B846F1}">
+                <asvg:svgBlip xmlns:asvg="http://schemas.microsoft.com/office/drawing/2016/SVG/main" r:embed="rId2"/>
+              </a:ext>
+            </a:extLst>
+          </a:blip>
+          <a:stretch>
+            <a:fillRect/>
+          </a:stretch>
+        </p:blipFill>
+        <p:spPr>
+          <a:xfrm>
+            <a:off x="11468100" y="266700"/>
+            <a:ext cx="381000" cy="381000"/>
+          </a:xfrm>
+          <a:prstGeom prst="rect">
+            <a:avLst/>
+          </a:prstGeom>
+        </p:spPr>
+      </p:pic>
+      <p:sp>
+        <p:nvSpPr>
+          <p:cNvPr id="3" name="Text 0"/>
+          <p:cNvSpPr/>
+          <p:nvPr/>
+        </p:nvSpPr>
+        <p:spPr>
+          <a:xfrm>
+            <a:off x="400050" y="457200"/>
+            <a:ext cx="1905000" cy="171450"/>
+          </a:xfrm>
+          <a:prstGeom prst="rect">
+            <a:avLst/>
+          </a:prstGeom>
+          <a:noFill/>
+          <a:ln/>
+        </p:spPr>
+        <p:txBody>
+          <a:bodyPr wrap="square" lIns="0" tIns="0" rIns="0" bIns="0" rtlCol="0" anchor="t"/>
+          <a:lstStyle/>
+          <a:p>
+            <a:pPr algn="l" indent="0" marL="0">
+              <a:buNone/>
+            </a:pPr>
+            <a:r>
+              <a:rPr lang="en-US" sz="1100" b="1" dirty="0">
+                <a:solidFill>
+                  <a:srgbClr val="E94560"/>
+                </a:solidFill>
+                <a:latin typeface="Helvetica Neue" pitchFamily="34" charset="0"/>
+                <a:ea typeface="Helvetica Neue" pitchFamily="34" charset="-122"/>
+                <a:cs typeface="Helvetica Neue" pitchFamily="34" charset="-120"/>
+              </a:rPr>
+              <a:t>NEXT</a:t>
+            </a:r>
+            <a:endParaRPr lang="en-US" sz="1100" dirty="0"/>
+          </a:p>
+        </p:txBody>
+      </p:sp>
+      <p:sp>
+        <p:nvSpPr>
+          <p:cNvPr id="4" name="Text 1"/>
+          <p:cNvSpPr/>
+          <p:nvPr/>
+        </p:nvSpPr>
+        <p:spPr>
+          <a:xfrm>
+            <a:off x="400050" y="1238250"/>
+            <a:ext cx="9525000" cy="1333500"/>
+          </a:xfrm>
+          <a:prstGeom prst="rect">
+            <a:avLst/>
+          </a:prstGeom>
+          <a:noFill/>
+          <a:ln/>
+        </p:spPr>
+        <p:txBody>
+          <a:bodyPr wrap="square" lIns="0" tIns="0" rIns="0" bIns="0" rtlCol="0" anchor="t"/>
+          <a:lstStyle/>
+          <a:p>
+            <a:pPr algn="l" indent="0" marL="0">
+              <a:buNone/>
+            </a:pPr>
+            <a:r>
+              <a:rPr lang="en-US" sz="4000" b="1" dirty="0">
+                <a:solidFill>
+                  <a:srgbClr val="EAEAEA"/>
+                </a:solidFill>
+                <a:latin typeface="Helvetica Neue" pitchFamily="34" charset="0"/>
+                <a:ea typeface="Helvetica Neue" pitchFamily="34" charset="-122"/>
+                <a:cs typeface="Helvetica Neue" pitchFamily="34" charset="-120"/>
+              </a:rPr>
+              <a:t>Author in YAML. Render with ppt-gen.</a:t>
+            </a:r>
+            <a:endParaRPr lang="en-US" sz="4000" dirty="0"/>
+          </a:p>
+        </p:txBody>
+      </p:sp>
+      <p:sp>
+        <p:nvSpPr>
+          <p:cNvPr id="5" name="Text 2"/>
+          <p:cNvSpPr/>
+          <p:nvPr/>
+        </p:nvSpPr>
+        <p:spPr>
+          <a:xfrm>
+            <a:off x="400050" y="2952750"/>
+            <a:ext cx="8572500" cy="571500"/>
+          </a:xfrm>
+          <a:prstGeom prst="rect">
+            <a:avLst/>
+          </a:prstGeom>
+          <a:noFill/>
+          <a:ln/>
+        </p:spPr>
+        <p:txBody>
+          <a:bodyPr wrap="square" lIns="0" tIns="0" rIns="0" bIns="0" rtlCol="0" anchor="t"/>
+          <a:lstStyle/>
+          <a:p>
+            <a:pPr algn="l" indent="0" marL="0">
+              <a:buNone/>
+            </a:pPr>
+            <a:r>
+              <a:rPr lang="en-US" sz="2000" dirty="0">
+                <a:solidFill>
+                  <a:srgbClr val="6C6C8A"/>
+                </a:solidFill>
+                <a:latin typeface="Helvetica Neue" pitchFamily="34" charset="0"/>
+                <a:ea typeface="Helvetica Neue" pitchFamily="34" charset="-122"/>
+                <a:cs typeface="Helvetica Neue" pitchFamily="34" charset="-120"/>
+              </a:rPr>
+              <a:t>Pick a pack layout, fill items, regenerate — same visual language every time.</a:t>
+            </a:r>
+            <a:endParaRPr lang="en-US" sz="2000" dirty="0"/>
+          </a:p>
+        </p:txBody>
+      </p:sp>
+      <p:sp>
+        <p:nvSpPr>
+          <p:cNvPr id="6" name="Text 3"/>
+          <p:cNvSpPr/>
+          <p:nvPr/>
+        </p:nvSpPr>
+        <p:spPr>
+          <a:xfrm>
+            <a:off x="400050" y="5619750"/>
+            <a:ext cx="10477500" cy="342900"/>
+          </a:xfrm>
+          <a:prstGeom prst="rect">
+            <a:avLst/>
+          </a:prstGeom>
+          <a:noFill/>
+          <a:ln/>
+        </p:spPr>
+        <p:txBody>
+          <a:bodyPr wrap="square" lIns="0" tIns="0" rIns="0" bIns="0" rtlCol="0" anchor="t"/>
+          <a:lstStyle/>
+          <a:p>
+            <a:pPr algn="l" indent="0" marL="0">
+              <a:buNone/>
+            </a:pPr>
+            <a:r>
+              <a:rPr lang="en-US" sz="1700" b="1" dirty="0">
+                <a:solidFill>
+                  <a:srgbClr val="EAEAEA"/>
+                </a:solidFill>
+                <a:latin typeface="Helvetica Neue" pitchFamily="34" charset="0"/>
+                <a:ea typeface="Helvetica Neue" pitchFamily="34" charset="-122"/>
+                <a:cs typeface="Helvetica Neue" pitchFamily="34" charset="-120"/>
+              </a:rPr>
+              <a:t>See README · Template packs (consulting / scientific / core)</a:t>
+            </a:r>
+            <a:endParaRPr lang="en-US" sz="1700" dirty="0"/>
+          </a:p>
+        </p:txBody>
+      </p:sp>
+      <p:sp>
+        <p:nvSpPr>
+          <p:cNvPr id="7" name="Text 4"/>
+          <p:cNvSpPr/>
+          <p:nvPr/>
+        </p:nvSpPr>
+        <p:spPr>
+          <a:xfrm>
+            <a:off x="400050" y="6457950"/>
+            <a:ext cx="4953000" cy="171450"/>
+          </a:xfrm>
+          <a:prstGeom prst="rect">
+            <a:avLst/>
+          </a:prstGeom>
+          <a:noFill/>
+          <a:ln/>
+        </p:spPr>
+        <p:txBody>
+          <a:bodyPr wrap="square" lIns="0" tIns="0" rIns="0" bIns="0" rtlCol="0" anchor="t"/>
+          <a:lstStyle/>
+          <a:p>
+            <a:pPr algn="l" indent="0" marL="0">
+              <a:buNone/>
+            </a:pPr>
+            <a:r>
+              <a:rPr lang="en-US" sz="1100" b="1" dirty="0">
+                <a:solidFill>
+                  <a:srgbClr val="6C6C8A"/>
+                </a:solidFill>
+                <a:latin typeface="Helvetica Neue" pitchFamily="34" charset="0"/>
+                <a:ea typeface="Helvetica Neue" pitchFamily="34" charset="-122"/>
+                <a:cs typeface="Helvetica Neue" pitchFamily="34" charset="-120"/>
+              </a:rPr>
+              <a:t>PPT-GEN  ·  TEMPLATE GALLERY</a:t>
+            </a:r>
+            <a:endParaRPr lang="en-US" sz="1100" dirty="0"/>
+          </a:p>
+        </p:txBody>
+      </p:sp>
+      <p:sp>
+        <p:nvSpPr>
+          <p:cNvPr id="8" name="Shape 5"/>
+          <p:cNvSpPr/>
+          <p:nvPr/>
+        </p:nvSpPr>
+        <p:spPr>
+          <a:xfrm>
+            <a:off x="5405438" y="6438900"/>
+            <a:ext cx="1381125" cy="209550"/>
+          </a:xfrm>
+          <a:prstGeom prst="roundRect">
+            <a:avLst>
+              <a:gd name="adj" fmla="val 43636"/>
+            </a:avLst>
+          </a:prstGeom>
+          <a:solidFill>
+            <a:srgbClr val="E94560"/>
+          </a:solidFill>
+          <a:ln w="12700">
+            <a:solidFill>
+              <a:srgbClr val="E94560"/>
+            </a:solidFill>
+            <a:prstDash val="solid"/>
+          </a:ln>
+        </p:spPr>
+      </p:sp>
+      <p:sp>
+        <p:nvSpPr>
+          <p:cNvPr id="9" name="Text 6"/>
+          <p:cNvSpPr/>
+          <p:nvPr/>
+        </p:nvSpPr>
+        <p:spPr>
+          <a:xfrm>
+            <a:off x="5405438" y="6457950"/>
+            <a:ext cx="1381125" cy="171450"/>
+          </a:xfrm>
+          <a:prstGeom prst="rect">
+            <a:avLst/>
+          </a:prstGeom>
+          <a:noFill/>
+          <a:ln/>
+        </p:spPr>
+        <p:txBody>
+          <a:bodyPr wrap="square" lIns="0" tIns="0" rIns="0" bIns="0" rtlCol="0" anchor="t"/>
+          <a:lstStyle/>
+          <a:p>
+            <a:pPr algn="ctr" indent="0" marL="0">
+              <a:buNone/>
+            </a:pPr>
+            <a:r>
+              <a:rPr lang="en-US" sz="1000" b="1" dirty="0">
+                <a:solidFill>
+                  <a:srgbClr val="FFFFFF"/>
+                </a:solidFill>
+                <a:latin typeface="Helvetica Neue" pitchFamily="34" charset="0"/>
+                <a:ea typeface="Helvetica Neue" pitchFamily="34" charset="-122"/>
+                <a:cs typeface="Helvetica Neue" pitchFamily="34" charset="-120"/>
+              </a:rPr>
+              <a:t>INTERNAL ONLY</a:t>
+            </a:r>
+            <a:endParaRPr lang="en-US" sz="1000" dirty="0"/>
+          </a:p>
+        </p:txBody>
+      </p:sp>
+      <p:sp>
+        <p:nvSpPr>
+          <p:cNvPr id="10" name="Text 7"/>
+          <p:cNvSpPr/>
+          <p:nvPr/>
+        </p:nvSpPr>
+        <p:spPr>
+          <a:xfrm>
+            <a:off x="11334750" y="6457950"/>
+            <a:ext cx="457200" cy="171450"/>
+          </a:xfrm>
+          <a:prstGeom prst="rect">
+            <a:avLst/>
+          </a:prstGeom>
+          <a:noFill/>
+          <a:ln/>
+        </p:spPr>
+        <p:txBody>
+          <a:bodyPr wrap="square" lIns="0" tIns="0" rIns="0" bIns="0" rtlCol="0" anchor="t"/>
+          <a:lstStyle/>
+          <a:p>
+            <a:pPr algn="r" indent="0" marL="0">
+              <a:buNone/>
+            </a:pPr>
+            <a:r>
+              <a:rPr lang="en-US" sz="1200" dirty="0">
+                <a:solidFill>
+                  <a:srgbClr val="6C6C8A"/>
+                </a:solidFill>
+                <a:latin typeface="Helvetica Neue" pitchFamily="34" charset="0"/>
+                <a:ea typeface="Helvetica Neue" pitchFamily="34" charset="-122"/>
+                <a:cs typeface="Helvetica Neue" pitchFamily="34" charset="-120"/>
+              </a:rPr>
+              <a:t>14</a:t>
             </a:r>
             <a:endParaRPr lang="en-US" sz="1200" dirty="0"/>
           </a:p>

</xml_diff>

<commit_message>
Show compose layouts across example decks.
Fold KPI/matrix/process pairs into cols, rows, main-side, and header-body slides and refresh committed PPTX previews.

Co-authored-by: Cursor <cursoragent@cursor.com>
</commit_message>
<xml_diff>
--- a/examples/template-gallery.pptx
+++ b/examples/template-gallery.pptx
@@ -19,9 +19,10 @@
     <p:sldId id="267" r:id="rId13"/>
     <p:sldId id="268" r:id="rId14"/>
     <p:sldId id="269" r:id="rId15"/>
+    <p:sldId id="270" r:id="rId16"/>
   </p:sldIdLst>
   <p:notesMasterIdLst>
-    <p:notesMasterId r:id="rId16"/>
+    <p:notesMasterId r:id="rId17"/>
   </p:notesMasterIdLst>
   <p:sldSz cx="12191695" cy="6858000"/>
   <p:notesSz cx="6858000" cy="12191695"/>
@@ -979,6 +980,94 @@
             <a:fld id="{F7021451-1387-4CA6-816F-3879F97B5CBC}" type="slidenum">
               <a:rPr lang="en-US"/>
               <a:t>14</a:t>
+            </a:fld>
+            <a:endParaRPr lang="en-US"/>
+          </a:p>
+        </p:txBody>
+      </p:sp>
+    </p:spTree>
+    <p:extLst>
+      <p:ext uri="{BB962C8B-B14F-4D97-AF65-F5344CB8AC3E}">
+        <p14:creationId xmlns:p14="http://schemas.microsoft.com/office/powerpoint/2010/main" val="1024086991"/>
+      </p:ext>
+    </p:extLst>
+  </p:cSld>
+  <p:clrMapOvr>
+    <a:masterClrMapping/>
+  </p:clrMapOvr>
+</p:notes>
+</file>
+
+<file path=ppt/notesSlides/notesSlide15.xml><?xml version="1.0" encoding="utf-8"?>
+<p:notes xmlns:a="http://schemas.openxmlformats.org/drawingml/2006/main" xmlns:r="http://schemas.openxmlformats.org/officeDocument/2006/relationships" xmlns:p="http://schemas.openxmlformats.org/presentationml/2006/main">
+  <p:cSld>
+    <p:spTree>
+      <p:nvGrpSpPr>
+        <p:cNvPr id="1" name=""/>
+        <p:cNvGrpSpPr/>
+        <p:nvPr/>
+      </p:nvGrpSpPr>
+      <p:grpSpPr>
+        <a:xfrm>
+          <a:off x="0" y="0"/>
+          <a:ext cx="0" cy="0"/>
+          <a:chOff x="0" y="0"/>
+          <a:chExt cx="0" cy="0"/>
+        </a:xfrm>
+      </p:grpSpPr>
+      <p:sp>
+        <p:nvSpPr>
+          <p:cNvPr id="2" name="Slide Image Placeholder 1"/>
+          <p:cNvSpPr>
+            <a:spLocks noGrp="1" noRot="1" noChangeAspect="1"/>
+          </p:cNvSpPr>
+          <p:nvPr>
+            <p:ph type="sldImg"/>
+          </p:nvPr>
+        </p:nvSpPr>
+        <p:spPr/>
+      </p:sp>
+      <p:sp>
+        <p:nvSpPr>
+          <p:cNvPr id="3" name="Notes Placeholder 2"/>
+          <p:cNvSpPr>
+            <a:spLocks noGrp="1"/>
+          </p:cNvSpPr>
+          <p:nvPr>
+            <p:ph type="body" idx="1"/>
+          </p:nvPr>
+        </p:nvSpPr>
+        <p:spPr/>
+        <p:txBody>
+          <a:bodyPr/>
+          <a:lstStyle/>
+          <a:p>
+            <a:r>
+              <a:rPr lang="en-US" dirty="0"/>
+              <a:t/>
+            </a:r>
+            <a:endParaRPr lang="en-US" dirty="0"/>
+          </a:p>
+        </p:txBody>
+      </p:sp>
+      <p:sp>
+        <p:nvSpPr>
+          <p:cNvPr id="4" name="Slide Number Placeholder 3"/>
+          <p:cNvSpPr>
+            <a:spLocks noGrp="1"/>
+          </p:cNvSpPr>
+          <p:nvPr>
+            <p:ph type="sldNum" sz="quarter" idx="10"/>
+          </p:nvPr>
+        </p:nvSpPr>
+        <p:spPr/>
+        <p:txBody>
+          <a:bodyPr/>
+          <a:lstStyle/>
+          <a:p>
+            <a:fld id="{F7021451-1387-4CA6-816F-3879F97B5CBC}" type="slidenum">
+              <a:rPr lang="en-US"/>
+              <a:t>15</a:t>
             </a:fld>
             <a:endParaRPr lang="en-US"/>
           </a:p>
@@ -6634,8 +6723,8 @@
         </p:nvSpPr>
         <p:spPr>
           <a:xfrm>
-            <a:off x="400050" y="457200"/>
-            <a:ext cx="1905000" cy="171450"/>
+            <a:off x="400050" y="247650"/>
+            <a:ext cx="10877550" cy="381000"/>
           </a:xfrm>
           <a:prstGeom prst="rect">
             <a:avLst/>
@@ -6651,140 +6740,23 @@
               <a:buNone/>
             </a:pPr>
             <a:r>
-              <a:rPr lang="en-US" sz="1100" b="1" dirty="0">
-                <a:solidFill>
-                  <a:srgbClr val="E94560"/>
-                </a:solidFill>
-                <a:latin typeface="Helvetica Neue" pitchFamily="34" charset="0"/>
-                <a:ea typeface="Helvetica Neue" pitchFamily="34" charset="-122"/>
-                <a:cs typeface="Helvetica Neue" pitchFamily="34" charset="-120"/>
-              </a:rPr>
-              <a:t>NEXT</a:t>
-            </a:r>
-            <a:endParaRPr lang="en-US" sz="1100" dirty="0"/>
+              <a:rPr lang="en-US" sz="3000" b="1" dirty="0">
+                <a:solidFill>
+                  <a:srgbClr val="EAEAEA"/>
+                </a:solidFill>
+                <a:latin typeface="Helvetica Neue" pitchFamily="34" charset="0"/>
+                <a:ea typeface="Helvetica Neue" pitchFamily="34" charset="-122"/>
+                <a:cs typeface="Helvetica Neue" pitchFamily="34" charset="-120"/>
+              </a:rPr>
+              <a:t>Compose — main + side stack</a:t>
+            </a:r>
+            <a:endParaRPr lang="en-US" sz="3000" dirty="0"/>
           </a:p>
         </p:txBody>
       </p:sp>
       <p:sp>
         <p:nvSpPr>
           <p:cNvPr id="4" name="Text 1"/>
-          <p:cNvSpPr/>
-          <p:nvPr/>
-        </p:nvSpPr>
-        <p:spPr>
-          <a:xfrm>
-            <a:off x="400050" y="1238250"/>
-            <a:ext cx="9525000" cy="1333500"/>
-          </a:xfrm>
-          <a:prstGeom prst="rect">
-            <a:avLst/>
-          </a:prstGeom>
-          <a:noFill/>
-          <a:ln/>
-        </p:spPr>
-        <p:txBody>
-          <a:bodyPr wrap="square" lIns="0" tIns="0" rIns="0" bIns="0" rtlCol="0" anchor="t"/>
-          <a:lstStyle/>
-          <a:p>
-            <a:pPr algn="l" indent="0" marL="0">
-              <a:buNone/>
-            </a:pPr>
-            <a:r>
-              <a:rPr lang="en-US" sz="4000" b="1" dirty="0">
-                <a:solidFill>
-                  <a:srgbClr val="EAEAEA"/>
-                </a:solidFill>
-                <a:latin typeface="Helvetica Neue" pitchFamily="34" charset="0"/>
-                <a:ea typeface="Helvetica Neue" pitchFamily="34" charset="-122"/>
-                <a:cs typeface="Helvetica Neue" pitchFamily="34" charset="-120"/>
-              </a:rPr>
-              <a:t>Author in YAML. Render with ppt-gen.</a:t>
-            </a:r>
-            <a:endParaRPr lang="en-US" sz="4000" dirty="0"/>
-          </a:p>
-        </p:txBody>
-      </p:sp>
-      <p:sp>
-        <p:nvSpPr>
-          <p:cNvPr id="5" name="Text 2"/>
-          <p:cNvSpPr/>
-          <p:nvPr/>
-        </p:nvSpPr>
-        <p:spPr>
-          <a:xfrm>
-            <a:off x="400050" y="2952750"/>
-            <a:ext cx="8572500" cy="571500"/>
-          </a:xfrm>
-          <a:prstGeom prst="rect">
-            <a:avLst/>
-          </a:prstGeom>
-          <a:noFill/>
-          <a:ln/>
-        </p:spPr>
-        <p:txBody>
-          <a:bodyPr wrap="square" lIns="0" tIns="0" rIns="0" bIns="0" rtlCol="0" anchor="t"/>
-          <a:lstStyle/>
-          <a:p>
-            <a:pPr algn="l" indent="0" marL="0">
-              <a:buNone/>
-            </a:pPr>
-            <a:r>
-              <a:rPr lang="en-US" sz="2000" dirty="0">
-                <a:solidFill>
-                  <a:srgbClr val="6C6C8A"/>
-                </a:solidFill>
-                <a:latin typeface="Helvetica Neue" pitchFamily="34" charset="0"/>
-                <a:ea typeface="Helvetica Neue" pitchFamily="34" charset="-122"/>
-                <a:cs typeface="Helvetica Neue" pitchFamily="34" charset="-120"/>
-              </a:rPr>
-              <a:t>Pick a pack layout, fill items, regenerate — same visual language every time.</a:t>
-            </a:r>
-            <a:endParaRPr lang="en-US" sz="2000" dirty="0"/>
-          </a:p>
-        </p:txBody>
-      </p:sp>
-      <p:sp>
-        <p:nvSpPr>
-          <p:cNvPr id="6" name="Text 3"/>
-          <p:cNvSpPr/>
-          <p:nvPr/>
-        </p:nvSpPr>
-        <p:spPr>
-          <a:xfrm>
-            <a:off x="400050" y="5619750"/>
-            <a:ext cx="10477500" cy="342900"/>
-          </a:xfrm>
-          <a:prstGeom prst="rect">
-            <a:avLst/>
-          </a:prstGeom>
-          <a:noFill/>
-          <a:ln/>
-        </p:spPr>
-        <p:txBody>
-          <a:bodyPr wrap="square" lIns="0" tIns="0" rIns="0" bIns="0" rtlCol="0" anchor="t"/>
-          <a:lstStyle/>
-          <a:p>
-            <a:pPr algn="l" indent="0" marL="0">
-              <a:buNone/>
-            </a:pPr>
-            <a:r>
-              <a:rPr lang="en-US" sz="1700" b="1" dirty="0">
-                <a:solidFill>
-                  <a:srgbClr val="EAEAEA"/>
-                </a:solidFill>
-                <a:latin typeface="Helvetica Neue" pitchFamily="34" charset="0"/>
-                <a:ea typeface="Helvetica Neue" pitchFamily="34" charset="-122"/>
-                <a:cs typeface="Helvetica Neue" pitchFamily="34" charset="-120"/>
-              </a:rPr>
-              <a:t>See README · Template packs (consulting / scientific / core)</a:t>
-            </a:r>
-            <a:endParaRPr lang="en-US" sz="1700" dirty="0"/>
-          </a:p>
-        </p:txBody>
-      </p:sp>
-      <p:sp>
-        <p:nvSpPr>
-          <p:cNvPr id="7" name="Text 4"/>
           <p:cNvSpPr/>
           <p:nvPr/>
         </p:nvSpPr>
@@ -6823,7 +6795,7 @@
       </p:sp>
       <p:sp>
         <p:nvSpPr>
-          <p:cNvPr id="8" name="Shape 5"/>
+          <p:cNvPr id="5" name="Shape 2"/>
           <p:cNvSpPr/>
           <p:nvPr/>
         </p:nvSpPr>
@@ -6850,7 +6822,7 @@
       </p:sp>
       <p:sp>
         <p:nvSpPr>
-          <p:cNvPr id="9" name="Text 6"/>
+          <p:cNvPr id="6" name="Text 3"/>
           <p:cNvSpPr/>
           <p:nvPr/>
         </p:nvSpPr>
@@ -6889,7 +6861,7 @@
       </p:sp>
       <p:sp>
         <p:nvSpPr>
-          <p:cNvPr id="10" name="Text 7"/>
+          <p:cNvPr id="7" name="Text 4"/>
           <p:cNvSpPr/>
           <p:nvPr/>
         </p:nvSpPr>
@@ -6921,6 +6893,1162 @@
                 <a:cs typeface="Helvetica Neue" pitchFamily="34" charset="-120"/>
               </a:rPr>
               <a:t>14</a:t>
+            </a:r>
+            <a:endParaRPr lang="en-US" sz="1200" dirty="0"/>
+          </a:p>
+        </p:txBody>
+      </p:sp>
+      <p:sp>
+        <p:nvSpPr>
+          <p:cNvPr id="8" name="Text 5"/>
+          <p:cNvSpPr/>
+          <p:nvPr/>
+        </p:nvSpPr>
+        <p:spPr>
+          <a:xfrm>
+            <a:off x="400050" y="819150"/>
+            <a:ext cx="6600825" cy="171450"/>
+          </a:xfrm>
+          <a:prstGeom prst="rect">
+            <a:avLst/>
+          </a:prstGeom>
+          <a:noFill/>
+          <a:ln/>
+        </p:spPr>
+        <p:txBody>
+          <a:bodyPr wrap="square" lIns="0" tIns="0" rIns="0" bIns="0" rtlCol="0" anchor="t"/>
+          <a:lstStyle/>
+          <a:p>
+            <a:pPr algn="l" indent="0" marL="0">
+              <a:buNone/>
+            </a:pPr>
+            <a:r>
+              <a:rPr lang="en-US" sz="1100" b="1" dirty="0">
+                <a:solidFill>
+                  <a:srgbClr val="6C6C8A"/>
+                </a:solidFill>
+                <a:latin typeface="Helvetica Neue" pitchFamily="34" charset="0"/>
+                <a:ea typeface="Helvetica Neue" pitchFamily="34" charset="-122"/>
+                <a:cs typeface="Helvetica Neue" pitchFamily="34" charset="-120"/>
+              </a:rPr>
+              <a:t>OVERLAP STORY</a:t>
+            </a:r>
+            <a:endParaRPr lang="en-US" sz="1100" dirty="0"/>
+          </a:p>
+        </p:txBody>
+      </p:sp>
+      <p:sp>
+        <p:nvSpPr>
+          <p:cNvPr id="9" name="Shape 6"/>
+          <p:cNvSpPr/>
+          <p:nvPr/>
+        </p:nvSpPr>
+        <p:spPr>
+          <a:xfrm>
+            <a:off x="1885950" y="2105025"/>
+            <a:ext cx="2238375" cy="2238375"/>
+          </a:xfrm>
+          <a:prstGeom prst="ellipse">
+            <a:avLst/>
+          </a:prstGeom>
+          <a:solidFill>
+            <a:srgbClr val="4E79A7">
+              <a:alpha val="45000"/>
+            </a:srgbClr>
+          </a:solidFill>
+          <a:ln w="19050">
+            <a:solidFill>
+              <a:srgbClr val="4E79A7"/>
+            </a:solidFill>
+            <a:prstDash val="solid"/>
+          </a:ln>
+        </p:spPr>
+      </p:sp>
+      <p:sp>
+        <p:nvSpPr>
+          <p:cNvPr id="10" name="Shape 7"/>
+          <p:cNvSpPr/>
+          <p:nvPr/>
+        </p:nvSpPr>
+        <p:spPr>
+          <a:xfrm>
+            <a:off x="3276600" y="2105025"/>
+            <a:ext cx="2238375" cy="2238375"/>
+          </a:xfrm>
+          <a:prstGeom prst="ellipse">
+            <a:avLst/>
+          </a:prstGeom>
+          <a:solidFill>
+            <a:srgbClr val="E94560">
+              <a:alpha val="45000"/>
+            </a:srgbClr>
+          </a:solidFill>
+          <a:ln w="19050">
+            <a:solidFill>
+              <a:srgbClr val="E94560"/>
+            </a:solidFill>
+            <a:prstDash val="solid"/>
+          </a:ln>
+        </p:spPr>
+      </p:sp>
+      <p:sp>
+        <p:nvSpPr>
+          <p:cNvPr id="11" name="Text 8"/>
+          <p:cNvSpPr/>
+          <p:nvPr/>
+        </p:nvSpPr>
+        <p:spPr>
+          <a:xfrm>
+            <a:off x="2019300" y="2733675"/>
+            <a:ext cx="942975" cy="809625"/>
+          </a:xfrm>
+          <a:prstGeom prst="rect">
+            <a:avLst/>
+          </a:prstGeom>
+          <a:noFill/>
+          <a:ln/>
+        </p:spPr>
+        <p:txBody>
+          <a:bodyPr wrap="square" lIns="0" tIns="0" rIns="0" bIns="0" rtlCol="0" anchor="ctr"/>
+          <a:lstStyle/>
+          <a:p>
+            <a:pPr algn="ctr" indent="0" marL="0">
+              <a:buNone/>
+            </a:pPr>
+            <a:r>
+              <a:rPr lang="en-US" sz="1600" b="1" dirty="0">
+                <a:solidFill>
+                  <a:srgbClr val="4E79A7"/>
+                </a:solidFill>
+                <a:latin typeface="Helvetica Neue" pitchFamily="34" charset="0"/>
+                <a:ea typeface="Helvetica Neue" pitchFamily="34" charset="-122"/>
+                <a:cs typeface="Helvetica Neue" pitchFamily="34" charset="-120"/>
+              </a:rPr>
+              <a:t>Product</a:t>
+            </a:r>
+            <a:endParaRPr lang="en-US" sz="1600" dirty="0"/>
+          </a:p>
+        </p:txBody>
+      </p:sp>
+      <p:sp>
+        <p:nvSpPr>
+          <p:cNvPr id="12" name="Text 9"/>
+          <p:cNvSpPr/>
+          <p:nvPr/>
+        </p:nvSpPr>
+        <p:spPr>
+          <a:xfrm>
+            <a:off x="4438650" y="2733675"/>
+            <a:ext cx="942975" cy="809625"/>
+          </a:xfrm>
+          <a:prstGeom prst="rect">
+            <a:avLst/>
+          </a:prstGeom>
+          <a:noFill/>
+          <a:ln/>
+        </p:spPr>
+        <p:txBody>
+          <a:bodyPr wrap="square" lIns="0" tIns="0" rIns="0" bIns="0" rtlCol="0" anchor="ctr"/>
+          <a:lstStyle/>
+          <a:p>
+            <a:pPr algn="ctr" indent="0" marL="0">
+              <a:buNone/>
+            </a:pPr>
+            <a:r>
+              <a:rPr lang="en-US" sz="1600" b="1" dirty="0">
+                <a:solidFill>
+                  <a:srgbClr val="E94560"/>
+                </a:solidFill>
+                <a:latin typeface="Helvetica Neue" pitchFamily="34" charset="0"/>
+                <a:ea typeface="Helvetica Neue" pitchFamily="34" charset="-122"/>
+                <a:cs typeface="Helvetica Neue" pitchFamily="34" charset="-120"/>
+              </a:rPr>
+              <a:t>GTM</a:t>
+            </a:r>
+            <a:endParaRPr lang="en-US" sz="1600" dirty="0"/>
+          </a:p>
+        </p:txBody>
+      </p:sp>
+      <p:sp>
+        <p:nvSpPr>
+          <p:cNvPr id="13" name="Text 10"/>
+          <p:cNvSpPr/>
+          <p:nvPr/>
+        </p:nvSpPr>
+        <p:spPr>
+          <a:xfrm>
+            <a:off x="3205163" y="2867025"/>
+            <a:ext cx="981075" cy="628650"/>
+          </a:xfrm>
+          <a:prstGeom prst="rect">
+            <a:avLst/>
+          </a:prstGeom>
+          <a:noFill/>
+          <a:ln/>
+        </p:spPr>
+        <p:txBody>
+          <a:bodyPr wrap="square" lIns="0" tIns="0" rIns="0" bIns="0" rtlCol="0" anchor="ctr"/>
+          <a:lstStyle/>
+          <a:p>
+            <a:pPr algn="ctr" indent="0" marL="0">
+              <a:buNone/>
+            </a:pPr>
+            <a:r>
+              <a:rPr lang="en-US" sz="1400" b="1" dirty="0">
+                <a:solidFill>
+                  <a:srgbClr val="EAEAEA"/>
+                </a:solidFill>
+                <a:latin typeface="Helvetica Neue" pitchFamily="34" charset="0"/>
+                <a:ea typeface="Helvetica Neue" pitchFamily="34" charset="-122"/>
+                <a:cs typeface="Helvetica Neue" pitchFamily="34" charset="-120"/>
+              </a:rPr>
+              <a:t>Retention</a:t>
+            </a:r>
+            <a:endParaRPr lang="en-US" sz="1400" dirty="0"/>
+          </a:p>
+        </p:txBody>
+      </p:sp>
+      <p:sp>
+        <p:nvSpPr>
+          <p:cNvPr id="14" name="Shape 11"/>
+          <p:cNvSpPr/>
+          <p:nvPr/>
+        </p:nvSpPr>
+        <p:spPr>
+          <a:xfrm>
+            <a:off x="400050" y="5200650"/>
+            <a:ext cx="2124075" cy="742950"/>
+          </a:xfrm>
+          <a:prstGeom prst="roundRect">
+            <a:avLst>
+              <a:gd name="adj" fmla="val 12308"/>
+            </a:avLst>
+          </a:prstGeom>
+          <a:solidFill>
+            <a:srgbClr val="2B2B4A"/>
+          </a:solidFill>
+          <a:ln w="12700">
+            <a:solidFill>
+              <a:srgbClr val="2B2B4A"/>
+            </a:solidFill>
+            <a:prstDash val="solid"/>
+          </a:ln>
+        </p:spPr>
+      </p:sp>
+      <p:sp>
+        <p:nvSpPr>
+          <p:cNvPr id="15" name="Shape 12"/>
+          <p:cNvSpPr/>
+          <p:nvPr/>
+        </p:nvSpPr>
+        <p:spPr>
+          <a:xfrm>
+            <a:off x="400050" y="5200650"/>
+            <a:ext cx="47625" cy="742950"/>
+          </a:xfrm>
+          <a:prstGeom prst="rect">
+            <a:avLst/>
+          </a:prstGeom>
+          <a:solidFill>
+            <a:srgbClr val="4E79A7"/>
+          </a:solidFill>
+          <a:ln w="12700">
+            <a:solidFill>
+              <a:srgbClr val="4E79A7"/>
+            </a:solidFill>
+            <a:prstDash val="solid"/>
+          </a:ln>
+        </p:spPr>
+      </p:sp>
+      <p:sp>
+        <p:nvSpPr>
+          <p:cNvPr id="16" name="Text 13"/>
+          <p:cNvSpPr/>
+          <p:nvPr/>
+        </p:nvSpPr>
+        <p:spPr>
+          <a:xfrm>
+            <a:off x="533400" y="5295900"/>
+            <a:ext cx="1895475" cy="552450"/>
+          </a:xfrm>
+          <a:prstGeom prst="rect">
+            <a:avLst/>
+          </a:prstGeom>
+          <a:noFill/>
+          <a:ln/>
+        </p:spPr>
+        <p:txBody>
+          <a:bodyPr wrap="square" lIns="0" tIns="0" rIns="0" bIns="0" rtlCol="0" anchor="ctr"/>
+          <a:lstStyle/>
+          <a:p>
+            <a:pPr algn="l" indent="0" marL="0">
+              <a:buNone/>
+            </a:pPr>
+            <a:r>
+              <a:rPr lang="en-US" sz="1300" dirty="0">
+                <a:solidFill>
+                  <a:srgbClr val="6C6C8A"/>
+                </a:solidFill>
+                <a:latin typeface="Helvetica Neue" pitchFamily="34" charset="0"/>
+                <a:ea typeface="Helvetica Neue" pitchFamily="34" charset="-122"/>
+                <a:cs typeface="Helvetica Neue" pitchFamily="34" charset="-120"/>
+              </a:rPr>
+              <a:t>Reliability</a:t>
+            </a:r>
+            <a:endParaRPr lang="en-US" sz="1300" dirty="0"/>
+          </a:p>
+        </p:txBody>
+      </p:sp>
+      <p:sp>
+        <p:nvSpPr>
+          <p:cNvPr id="17" name="Shape 14"/>
+          <p:cNvSpPr/>
+          <p:nvPr/>
+        </p:nvSpPr>
+        <p:spPr>
+          <a:xfrm>
+            <a:off x="2638425" y="5200650"/>
+            <a:ext cx="2124075" cy="742950"/>
+          </a:xfrm>
+          <a:prstGeom prst="roundRect">
+            <a:avLst>
+              <a:gd name="adj" fmla="val 12308"/>
+            </a:avLst>
+          </a:prstGeom>
+          <a:solidFill>
+            <a:srgbClr val="2B2B4A"/>
+          </a:solidFill>
+          <a:ln w="12700">
+            <a:solidFill>
+              <a:srgbClr val="2B2B4A"/>
+            </a:solidFill>
+            <a:prstDash val="solid"/>
+          </a:ln>
+        </p:spPr>
+      </p:sp>
+      <p:sp>
+        <p:nvSpPr>
+          <p:cNvPr id="18" name="Shape 15"/>
+          <p:cNvSpPr/>
+          <p:nvPr/>
+        </p:nvSpPr>
+        <p:spPr>
+          <a:xfrm>
+            <a:off x="2638425" y="5200650"/>
+            <a:ext cx="47625" cy="742950"/>
+          </a:xfrm>
+          <a:prstGeom prst="rect">
+            <a:avLst/>
+          </a:prstGeom>
+          <a:solidFill>
+            <a:srgbClr val="E94560"/>
+          </a:solidFill>
+          <a:ln w="12700">
+            <a:solidFill>
+              <a:srgbClr val="E94560"/>
+            </a:solidFill>
+            <a:prstDash val="solid"/>
+          </a:ln>
+        </p:spPr>
+      </p:sp>
+      <p:sp>
+        <p:nvSpPr>
+          <p:cNvPr id="19" name="Text 16"/>
+          <p:cNvSpPr/>
+          <p:nvPr/>
+        </p:nvSpPr>
+        <p:spPr>
+          <a:xfrm>
+            <a:off x="2771775" y="5295900"/>
+            <a:ext cx="1895475" cy="552450"/>
+          </a:xfrm>
+          <a:prstGeom prst="rect">
+            <a:avLst/>
+          </a:prstGeom>
+          <a:noFill/>
+          <a:ln/>
+        </p:spPr>
+        <p:txBody>
+          <a:bodyPr wrap="square" lIns="0" tIns="0" rIns="0" bIns="0" rtlCol="0" anchor="ctr"/>
+          <a:lstStyle/>
+          <a:p>
+            <a:pPr algn="l" indent="0" marL="0">
+              <a:buNone/>
+            </a:pPr>
+            <a:r>
+              <a:rPr lang="en-US" sz="1300" dirty="0">
+                <a:solidFill>
+                  <a:srgbClr val="6C6C8A"/>
+                </a:solidFill>
+                <a:latin typeface="Helvetica Neue" pitchFamily="34" charset="0"/>
+                <a:ea typeface="Helvetica Neue" pitchFamily="34" charset="-122"/>
+                <a:cs typeface="Helvetica Neue" pitchFamily="34" charset="-120"/>
+              </a:rPr>
+              <a:t>Habit</a:t>
+            </a:r>
+            <a:endParaRPr lang="en-US" sz="1300" dirty="0"/>
+          </a:p>
+        </p:txBody>
+      </p:sp>
+      <p:sp>
+        <p:nvSpPr>
+          <p:cNvPr id="20" name="Shape 17"/>
+          <p:cNvSpPr/>
+          <p:nvPr/>
+        </p:nvSpPr>
+        <p:spPr>
+          <a:xfrm>
+            <a:off x="4876800" y="5200650"/>
+            <a:ext cx="2124075" cy="742950"/>
+          </a:xfrm>
+          <a:prstGeom prst="roundRect">
+            <a:avLst>
+              <a:gd name="adj" fmla="val 12308"/>
+            </a:avLst>
+          </a:prstGeom>
+          <a:solidFill>
+            <a:srgbClr val="2B2B4A"/>
+          </a:solidFill>
+          <a:ln w="12700">
+            <a:solidFill>
+              <a:srgbClr val="2B2B4A"/>
+            </a:solidFill>
+            <a:prstDash val="solid"/>
+          </a:ln>
+        </p:spPr>
+      </p:sp>
+      <p:sp>
+        <p:nvSpPr>
+          <p:cNvPr id="21" name="Shape 18"/>
+          <p:cNvSpPr/>
+          <p:nvPr/>
+        </p:nvSpPr>
+        <p:spPr>
+          <a:xfrm>
+            <a:off x="4876800" y="5200650"/>
+            <a:ext cx="47625" cy="742950"/>
+          </a:xfrm>
+          <a:prstGeom prst="rect">
+            <a:avLst/>
+          </a:prstGeom>
+          <a:solidFill>
+            <a:srgbClr val="E94560"/>
+          </a:solidFill>
+          <a:ln w="12700">
+            <a:solidFill>
+              <a:srgbClr val="E94560"/>
+            </a:solidFill>
+            <a:prstDash val="solid"/>
+          </a:ln>
+        </p:spPr>
+      </p:sp>
+      <p:sp>
+        <p:nvSpPr>
+          <p:cNvPr id="22" name="Text 19"/>
+          <p:cNvSpPr/>
+          <p:nvPr/>
+        </p:nvSpPr>
+        <p:spPr>
+          <a:xfrm>
+            <a:off x="5010150" y="5295900"/>
+            <a:ext cx="1895475" cy="552450"/>
+          </a:xfrm>
+          <a:prstGeom prst="rect">
+            <a:avLst/>
+          </a:prstGeom>
+          <a:noFill/>
+          <a:ln/>
+        </p:spPr>
+        <p:txBody>
+          <a:bodyPr wrap="square" lIns="0" tIns="0" rIns="0" bIns="0" rtlCol="0" anchor="ctr"/>
+          <a:lstStyle/>
+          <a:p>
+            <a:pPr algn="l" indent="0" marL="0">
+              <a:buNone/>
+            </a:pPr>
+            <a:r>
+              <a:rPr lang="en-US" sz="1300" dirty="0">
+                <a:solidFill>
+                  <a:srgbClr val="6C6C8A"/>
+                </a:solidFill>
+                <a:latin typeface="Helvetica Neue" pitchFamily="34" charset="0"/>
+                <a:ea typeface="Helvetica Neue" pitchFamily="34" charset="-122"/>
+                <a:cs typeface="Helvetica Neue" pitchFamily="34" charset="-120"/>
+              </a:rPr>
+              <a:t>Narrative</a:t>
+            </a:r>
+            <a:endParaRPr lang="en-US" sz="1300" dirty="0"/>
+          </a:p>
+        </p:txBody>
+      </p:sp>
+      <p:sp>
+        <p:nvSpPr>
+          <p:cNvPr id="23" name="Text 20"/>
+          <p:cNvSpPr/>
+          <p:nvPr/>
+        </p:nvSpPr>
+        <p:spPr>
+          <a:xfrm>
+            <a:off x="7153275" y="819150"/>
+            <a:ext cx="4638675" cy="171450"/>
+          </a:xfrm>
+          <a:prstGeom prst="rect">
+            <a:avLst/>
+          </a:prstGeom>
+          <a:noFill/>
+          <a:ln/>
+        </p:spPr>
+        <p:txBody>
+          <a:bodyPr wrap="square" lIns="0" tIns="0" rIns="0" bIns="0" rtlCol="0" anchor="t"/>
+          <a:lstStyle/>
+          <a:p>
+            <a:pPr algn="l" indent="0" marL="0">
+              <a:buNone/>
+            </a:pPr>
+            <a:r>
+              <a:rPr lang="en-US" sz="1100" b="1" dirty="0">
+                <a:solidFill>
+                  <a:srgbClr val="6C6C8A"/>
+                </a:solidFill>
+                <a:latin typeface="Helvetica Neue" pitchFamily="34" charset="0"/>
+                <a:ea typeface="Helvetica Neue" pitchFamily="34" charset="-122"/>
+                <a:cs typeface="Helvetica Neue" pitchFamily="34" charset="-120"/>
+              </a:rPr>
+              <a:t>SIGNAL</a:t>
+            </a:r>
+            <a:endParaRPr lang="en-US" sz="1100" dirty="0"/>
+          </a:p>
+        </p:txBody>
+      </p:sp>
+      <p:sp>
+        <p:nvSpPr>
+          <p:cNvPr id="24" name="Shape 21"/>
+          <p:cNvSpPr/>
+          <p:nvPr/>
+        </p:nvSpPr>
+        <p:spPr>
+          <a:xfrm>
+            <a:off x="7153275" y="1143000"/>
+            <a:ext cx="4638675" cy="2343150"/>
+          </a:xfrm>
+          <a:prstGeom prst="roundRect">
+            <a:avLst>
+              <a:gd name="adj" fmla="val 3902"/>
+            </a:avLst>
+          </a:prstGeom>
+          <a:solidFill>
+            <a:srgbClr val="2B2B4A"/>
+          </a:solidFill>
+          <a:ln w="12700">
+            <a:solidFill>
+              <a:srgbClr val="2B2B4A"/>
+            </a:solidFill>
+            <a:prstDash val="solid"/>
+          </a:ln>
+        </p:spPr>
+      </p:sp>
+      <p:sp>
+        <p:nvSpPr>
+          <p:cNvPr id="25" name="Shape 22"/>
+          <p:cNvSpPr/>
+          <p:nvPr/>
+        </p:nvSpPr>
+        <p:spPr>
+          <a:xfrm>
+            <a:off x="7153275" y="1143000"/>
+            <a:ext cx="4638675" cy="76200"/>
+          </a:xfrm>
+          <a:prstGeom prst="rect">
+            <a:avLst/>
+          </a:prstGeom>
+          <a:solidFill>
+            <a:srgbClr val="4E79A7"/>
+          </a:solidFill>
+          <a:ln w="12700">
+            <a:solidFill>
+              <a:srgbClr val="4E79A7"/>
+            </a:solidFill>
+            <a:prstDash val="solid"/>
+          </a:ln>
+        </p:spPr>
+      </p:sp>
+      <p:sp>
+        <p:nvSpPr>
+          <p:cNvPr id="26" name="Text 23"/>
+          <p:cNvSpPr/>
+          <p:nvPr/>
+        </p:nvSpPr>
+        <p:spPr>
+          <a:xfrm>
+            <a:off x="7343775" y="1390650"/>
+            <a:ext cx="4257675" cy="171450"/>
+          </a:xfrm>
+          <a:prstGeom prst="rect">
+            <a:avLst/>
+          </a:prstGeom>
+          <a:noFill/>
+          <a:ln/>
+        </p:spPr>
+        <p:txBody>
+          <a:bodyPr wrap="square" lIns="0" tIns="0" rIns="0" bIns="0" rtlCol="0" anchor="t"/>
+          <a:lstStyle/>
+          <a:p>
+            <a:pPr algn="l" indent="0" marL="0">
+              <a:buNone/>
+            </a:pPr>
+            <a:r>
+              <a:rPr lang="en-US" sz="1100" b="1" dirty="0">
+                <a:solidFill>
+                  <a:srgbClr val="6C6C8A"/>
+                </a:solidFill>
+                <a:latin typeface="Helvetica Neue" pitchFamily="34" charset="0"/>
+                <a:ea typeface="Helvetica Neue" pitchFamily="34" charset="-122"/>
+                <a:cs typeface="Helvetica Neue" pitchFamily="34" charset="-120"/>
+              </a:rPr>
+              <a:t>NPS</a:t>
+            </a:r>
+            <a:endParaRPr lang="en-US" sz="1100" dirty="0"/>
+          </a:p>
+        </p:txBody>
+      </p:sp>
+      <p:sp>
+        <p:nvSpPr>
+          <p:cNvPr id="27" name="Text 24"/>
+          <p:cNvSpPr/>
+          <p:nvPr/>
+        </p:nvSpPr>
+        <p:spPr>
+          <a:xfrm>
+            <a:off x="7343775" y="1790700"/>
+            <a:ext cx="4257675" cy="1009650"/>
+          </a:xfrm>
+          <a:prstGeom prst="rect">
+            <a:avLst/>
+          </a:prstGeom>
+          <a:noFill/>
+          <a:ln/>
+        </p:spPr>
+        <p:txBody>
+          <a:bodyPr wrap="none" lIns="0" tIns="0" rIns="0" bIns="0" rtlCol="0" anchor="ctr"/>
+          <a:lstStyle/>
+          <a:p>
+            <a:pPr algn="l" indent="0" marL="0">
+              <a:buNone/>
+            </a:pPr>
+            <a:r>
+              <a:rPr lang="en-US" sz="4000" b="1" dirty="0">
+                <a:solidFill>
+                  <a:srgbClr val="4E79A7"/>
+                </a:solidFill>
+                <a:latin typeface="Helvetica Neue" pitchFamily="34" charset="0"/>
+                <a:ea typeface="Helvetica Neue" pitchFamily="34" charset="-122"/>
+                <a:cs typeface="Helvetica Neue" pitchFamily="34" charset="-120"/>
+              </a:rPr>
+              <a:t>+12</a:t>
+            </a:r>
+            <a:endParaRPr lang="en-US" sz="4000" dirty="0"/>
+          </a:p>
+        </p:txBody>
+      </p:sp>
+      <p:sp>
+        <p:nvSpPr>
+          <p:cNvPr id="28" name="Text 25"/>
+          <p:cNvSpPr/>
+          <p:nvPr/>
+        </p:nvSpPr>
+        <p:spPr>
+          <a:xfrm>
+            <a:off x="7343775" y="2933700"/>
+            <a:ext cx="4257675" cy="381000"/>
+          </a:xfrm>
+          <a:prstGeom prst="rect">
+            <a:avLst/>
+          </a:prstGeom>
+          <a:noFill/>
+          <a:ln/>
+        </p:spPr>
+        <p:txBody>
+          <a:bodyPr wrap="square" lIns="0" tIns="0" rIns="0" bIns="0" rtlCol="0" anchor="t"/>
+          <a:lstStyle/>
+          <a:p>
+            <a:pPr algn="l" indent="0" marL="0">
+              <a:buNone/>
+            </a:pPr>
+            <a:r>
+              <a:rPr lang="en-US" sz="1300" dirty="0">
+                <a:solidFill>
+                  <a:srgbClr val="6C6C8A"/>
+                </a:solidFill>
+                <a:latin typeface="Helvetica Neue" pitchFamily="34" charset="0"/>
+                <a:ea typeface="Helvetica Neue" pitchFamily="34" charset="-122"/>
+                <a:cs typeface="Helvetica Neue" pitchFamily="34" charset="-120"/>
+              </a:rPr>
+              <a:t>Trailing 90d</a:t>
+            </a:r>
+            <a:endParaRPr lang="en-US" sz="1300" dirty="0"/>
+          </a:p>
+        </p:txBody>
+      </p:sp>
+      <p:sp>
+        <p:nvSpPr>
+          <p:cNvPr id="29" name="Text 26"/>
+          <p:cNvSpPr/>
+          <p:nvPr/>
+        </p:nvSpPr>
+        <p:spPr>
+          <a:xfrm>
+            <a:off x="7153275" y="3543300"/>
+            <a:ext cx="4638675" cy="171450"/>
+          </a:xfrm>
+          <a:prstGeom prst="rect">
+            <a:avLst/>
+          </a:prstGeom>
+          <a:noFill/>
+          <a:ln/>
+        </p:spPr>
+        <p:txBody>
+          <a:bodyPr wrap="square" lIns="0" tIns="0" rIns="0" bIns="0" rtlCol="0" anchor="t"/>
+          <a:lstStyle/>
+          <a:p>
+            <a:pPr algn="l" indent="0" marL="0">
+              <a:buNone/>
+            </a:pPr>
+            <a:r>
+              <a:rPr lang="en-US" sz="1100" b="1" dirty="0">
+                <a:solidFill>
+                  <a:srgbClr val="6C6C8A"/>
+                </a:solidFill>
+                <a:latin typeface="Helvetica Neue" pitchFamily="34" charset="0"/>
+                <a:ea typeface="Helvetica Neue" pitchFamily="34" charset="-122"/>
+                <a:cs typeface="Helvetica Neue" pitchFamily="34" charset="-120"/>
+              </a:rPr>
+              <a:t>DECISION</a:t>
+            </a:r>
+            <a:endParaRPr lang="en-US" sz="1100" dirty="0"/>
+          </a:p>
+        </p:txBody>
+      </p:sp>
+      <p:sp>
+        <p:nvSpPr>
+          <p:cNvPr id="30" name="Shape 27"/>
+          <p:cNvSpPr/>
+          <p:nvPr/>
+        </p:nvSpPr>
+        <p:spPr>
+          <a:xfrm>
+            <a:off x="7153275" y="3752850"/>
+            <a:ext cx="114300" cy="2571750"/>
+          </a:xfrm>
+          <a:prstGeom prst="rect">
+            <a:avLst/>
+          </a:prstGeom>
+          <a:solidFill>
+            <a:srgbClr val="E94560"/>
+          </a:solidFill>
+          <a:ln w="12700">
+            <a:solidFill>
+              <a:srgbClr val="E94560"/>
+            </a:solidFill>
+            <a:prstDash val="solid"/>
+          </a:ln>
+        </p:spPr>
+      </p:sp>
+      <p:sp>
+        <p:nvSpPr>
+          <p:cNvPr id="31" name="Text 28"/>
+          <p:cNvSpPr/>
+          <p:nvPr/>
+        </p:nvSpPr>
+        <p:spPr>
+          <a:xfrm>
+            <a:off x="7553325" y="4095750"/>
+            <a:ext cx="3876675" cy="1885950"/>
+          </a:xfrm>
+          <a:prstGeom prst="rect">
+            <a:avLst/>
+          </a:prstGeom>
+          <a:noFill/>
+          <a:ln/>
+        </p:spPr>
+        <p:txBody>
+          <a:bodyPr wrap="square" lIns="0" tIns="0" rIns="0" bIns="0" rtlCol="0" anchor="ctr"/>
+          <a:lstStyle/>
+          <a:p>
+            <a:pPr algn="l" indent="0" marL="0">
+              <a:buNone/>
+            </a:pPr>
+            <a:r>
+              <a:rPr lang="en-US" sz="2800" b="1" dirty="0">
+                <a:solidFill>
+                  <a:srgbClr val="EAEAEA"/>
+                </a:solidFill>
+                <a:latin typeface="Helvetica Neue" pitchFamily="34" charset="0"/>
+                <a:ea typeface="Helvetica Neue" pitchFamily="34" charset="-122"/>
+                <a:cs typeface="Helvetica Neue" pitchFamily="34" charset="-120"/>
+              </a:rPr>
+              <a:t>Fund the habit-loop bet; pause vanity dashboards.</a:t>
+            </a:r>
+            <a:endParaRPr lang="en-US" sz="2800" dirty="0"/>
+          </a:p>
+        </p:txBody>
+      </p:sp>
+    </p:spTree>
+  </p:cSld>
+  <p:clrMapOvr>
+    <a:masterClrMapping/>
+  </p:clrMapOvr>
+</p:sld>
+</file>
+
+<file path=ppt/slides/slide15.xml><?xml version="1.0" encoding="utf-8"?>
+<p:sld xmlns:a="http://schemas.openxmlformats.org/drawingml/2006/main" xmlns:r="http://schemas.openxmlformats.org/officeDocument/2006/relationships" xmlns:p="http://schemas.openxmlformats.org/presentationml/2006/main">
+  <p:cSld name="Slide 15">
+    <p:bg>
+      <p:bgPr>
+        <a:solidFill>
+          <a:srgbClr val="1A1A2E"/>
+        </a:solidFill>
+      </p:bgPr>
+    </p:bg>
+    <p:spTree>
+      <p:nvGrpSpPr>
+        <p:cNvPr id="1" name=""/>
+        <p:cNvGrpSpPr/>
+        <p:nvPr/>
+      </p:nvGrpSpPr>
+      <p:grpSpPr>
+        <a:xfrm>
+          <a:off x="0" y="0"/>
+          <a:ext cx="0" cy="0"/>
+          <a:chOff x="0" y="0"/>
+          <a:chExt cx="0" cy="0"/>
+        </a:xfrm>
+      </p:grpSpPr>
+      <p:pic>
+        <p:nvPicPr>
+          <p:cNvPr id="2" name="Image 0" descr="/Users/dpadmana/projects/ppt-gen/assets/brand/logo.svg">    </p:cNvPr>
+          <p:cNvPicPr>
+            <a:picLocks noChangeAspect="1"/>
+          </p:cNvPicPr>
+          <p:nvPr/>
+        </p:nvPicPr>
+        <p:blipFill>
+          <a:blip r:embed="rId1">
+            <a:extLst>
+              <a:ext uri="{96DAC541-7B7A-43D3-8B79-37D633B846F1}">
+                <asvg:svgBlip xmlns:asvg="http://schemas.microsoft.com/office/drawing/2016/SVG/main" r:embed="rId2"/>
+              </a:ext>
+            </a:extLst>
+          </a:blip>
+          <a:stretch>
+            <a:fillRect/>
+          </a:stretch>
+        </p:blipFill>
+        <p:spPr>
+          <a:xfrm>
+            <a:off x="11468100" y="266700"/>
+            <a:ext cx="381000" cy="381000"/>
+          </a:xfrm>
+          <a:prstGeom prst="rect">
+            <a:avLst/>
+          </a:prstGeom>
+        </p:spPr>
+      </p:pic>
+      <p:sp>
+        <p:nvSpPr>
+          <p:cNvPr id="3" name="Text 0"/>
+          <p:cNvSpPr/>
+          <p:nvPr/>
+        </p:nvSpPr>
+        <p:spPr>
+          <a:xfrm>
+            <a:off x="400050" y="457200"/>
+            <a:ext cx="1905000" cy="171450"/>
+          </a:xfrm>
+          <a:prstGeom prst="rect">
+            <a:avLst/>
+          </a:prstGeom>
+          <a:noFill/>
+          <a:ln/>
+        </p:spPr>
+        <p:txBody>
+          <a:bodyPr wrap="square" lIns="0" tIns="0" rIns="0" bIns="0" rtlCol="0" anchor="t"/>
+          <a:lstStyle/>
+          <a:p>
+            <a:pPr algn="l" indent="0" marL="0">
+              <a:buNone/>
+            </a:pPr>
+            <a:r>
+              <a:rPr lang="en-US" sz="1100" b="1" dirty="0">
+                <a:solidFill>
+                  <a:srgbClr val="E94560"/>
+                </a:solidFill>
+                <a:latin typeface="Helvetica Neue" pitchFamily="34" charset="0"/>
+                <a:ea typeface="Helvetica Neue" pitchFamily="34" charset="-122"/>
+                <a:cs typeface="Helvetica Neue" pitchFamily="34" charset="-120"/>
+              </a:rPr>
+              <a:t>NEXT</a:t>
+            </a:r>
+            <a:endParaRPr lang="en-US" sz="1100" dirty="0"/>
+          </a:p>
+        </p:txBody>
+      </p:sp>
+      <p:sp>
+        <p:nvSpPr>
+          <p:cNvPr id="4" name="Text 1"/>
+          <p:cNvSpPr/>
+          <p:nvPr/>
+        </p:nvSpPr>
+        <p:spPr>
+          <a:xfrm>
+            <a:off x="400050" y="1238250"/>
+            <a:ext cx="9525000" cy="1333500"/>
+          </a:xfrm>
+          <a:prstGeom prst="rect">
+            <a:avLst/>
+          </a:prstGeom>
+          <a:noFill/>
+          <a:ln/>
+        </p:spPr>
+        <p:txBody>
+          <a:bodyPr wrap="square" lIns="0" tIns="0" rIns="0" bIns="0" rtlCol="0" anchor="t"/>
+          <a:lstStyle/>
+          <a:p>
+            <a:pPr algn="l" indent="0" marL="0">
+              <a:buNone/>
+            </a:pPr>
+            <a:r>
+              <a:rPr lang="en-US" sz="4000" b="1" dirty="0">
+                <a:solidFill>
+                  <a:srgbClr val="EAEAEA"/>
+                </a:solidFill>
+                <a:latin typeface="Helvetica Neue" pitchFamily="34" charset="0"/>
+                <a:ea typeface="Helvetica Neue" pitchFamily="34" charset="-122"/>
+                <a:cs typeface="Helvetica Neue" pitchFamily="34" charset="-120"/>
+              </a:rPr>
+              <a:t>Author in YAML. Render with ppt-gen.</a:t>
+            </a:r>
+            <a:endParaRPr lang="en-US" sz="4000" dirty="0"/>
+          </a:p>
+        </p:txBody>
+      </p:sp>
+      <p:sp>
+        <p:nvSpPr>
+          <p:cNvPr id="5" name="Text 2"/>
+          <p:cNvSpPr/>
+          <p:nvPr/>
+        </p:nvSpPr>
+        <p:spPr>
+          <a:xfrm>
+            <a:off x="400050" y="2952750"/>
+            <a:ext cx="8572500" cy="571500"/>
+          </a:xfrm>
+          <a:prstGeom prst="rect">
+            <a:avLst/>
+          </a:prstGeom>
+          <a:noFill/>
+          <a:ln/>
+        </p:spPr>
+        <p:txBody>
+          <a:bodyPr wrap="square" lIns="0" tIns="0" rIns="0" bIns="0" rtlCol="0" anchor="t"/>
+          <a:lstStyle/>
+          <a:p>
+            <a:pPr algn="l" indent="0" marL="0">
+              <a:buNone/>
+            </a:pPr>
+            <a:r>
+              <a:rPr lang="en-US" sz="2000" dirty="0">
+                <a:solidFill>
+                  <a:srgbClr val="6C6C8A"/>
+                </a:solidFill>
+                <a:latin typeface="Helvetica Neue" pitchFamily="34" charset="0"/>
+                <a:ea typeface="Helvetica Neue" pitchFamily="34" charset="-122"/>
+                <a:cs typeface="Helvetica Neue" pitchFamily="34" charset="-120"/>
+              </a:rPr>
+              <a:t>Pick a pack layout, fill items, regenerate — same visual language every time.</a:t>
+            </a:r>
+            <a:endParaRPr lang="en-US" sz="2000" dirty="0"/>
+          </a:p>
+        </p:txBody>
+      </p:sp>
+      <p:sp>
+        <p:nvSpPr>
+          <p:cNvPr id="6" name="Text 3"/>
+          <p:cNvSpPr/>
+          <p:nvPr/>
+        </p:nvSpPr>
+        <p:spPr>
+          <a:xfrm>
+            <a:off x="400050" y="5619750"/>
+            <a:ext cx="10477500" cy="342900"/>
+          </a:xfrm>
+          <a:prstGeom prst="rect">
+            <a:avLst/>
+          </a:prstGeom>
+          <a:noFill/>
+          <a:ln/>
+        </p:spPr>
+        <p:txBody>
+          <a:bodyPr wrap="square" lIns="0" tIns="0" rIns="0" bIns="0" rtlCol="0" anchor="t"/>
+          <a:lstStyle/>
+          <a:p>
+            <a:pPr algn="l" indent="0" marL="0">
+              <a:buNone/>
+            </a:pPr>
+            <a:r>
+              <a:rPr lang="en-US" sz="1700" b="1" dirty="0">
+                <a:solidFill>
+                  <a:srgbClr val="EAEAEA"/>
+                </a:solidFill>
+                <a:latin typeface="Helvetica Neue" pitchFamily="34" charset="0"/>
+                <a:ea typeface="Helvetica Neue" pitchFamily="34" charset="-122"/>
+                <a:cs typeface="Helvetica Neue" pitchFamily="34" charset="-120"/>
+              </a:rPr>
+              <a:t>See README · Template packs (consulting / scientific / core) · compose for multi-panel slides</a:t>
+            </a:r>
+            <a:endParaRPr lang="en-US" sz="1700" dirty="0"/>
+          </a:p>
+        </p:txBody>
+      </p:sp>
+      <p:sp>
+        <p:nvSpPr>
+          <p:cNvPr id="7" name="Text 4"/>
+          <p:cNvSpPr/>
+          <p:nvPr/>
+        </p:nvSpPr>
+        <p:spPr>
+          <a:xfrm>
+            <a:off x="400050" y="6457950"/>
+            <a:ext cx="4953000" cy="171450"/>
+          </a:xfrm>
+          <a:prstGeom prst="rect">
+            <a:avLst/>
+          </a:prstGeom>
+          <a:noFill/>
+          <a:ln/>
+        </p:spPr>
+        <p:txBody>
+          <a:bodyPr wrap="square" lIns="0" tIns="0" rIns="0" bIns="0" rtlCol="0" anchor="t"/>
+          <a:lstStyle/>
+          <a:p>
+            <a:pPr algn="l" indent="0" marL="0">
+              <a:buNone/>
+            </a:pPr>
+            <a:r>
+              <a:rPr lang="en-US" sz="1100" b="1" dirty="0">
+                <a:solidFill>
+                  <a:srgbClr val="6C6C8A"/>
+                </a:solidFill>
+                <a:latin typeface="Helvetica Neue" pitchFamily="34" charset="0"/>
+                <a:ea typeface="Helvetica Neue" pitchFamily="34" charset="-122"/>
+                <a:cs typeface="Helvetica Neue" pitchFamily="34" charset="-120"/>
+              </a:rPr>
+              <a:t>PPT-GEN  ·  TEMPLATE GALLERY</a:t>
+            </a:r>
+            <a:endParaRPr lang="en-US" sz="1100" dirty="0"/>
+          </a:p>
+        </p:txBody>
+      </p:sp>
+      <p:sp>
+        <p:nvSpPr>
+          <p:cNvPr id="8" name="Shape 5"/>
+          <p:cNvSpPr/>
+          <p:nvPr/>
+        </p:nvSpPr>
+        <p:spPr>
+          <a:xfrm>
+            <a:off x="5405438" y="6438900"/>
+            <a:ext cx="1381125" cy="209550"/>
+          </a:xfrm>
+          <a:prstGeom prst="roundRect">
+            <a:avLst>
+              <a:gd name="adj" fmla="val 43636"/>
+            </a:avLst>
+          </a:prstGeom>
+          <a:solidFill>
+            <a:srgbClr val="E94560"/>
+          </a:solidFill>
+          <a:ln w="12700">
+            <a:solidFill>
+              <a:srgbClr val="E94560"/>
+            </a:solidFill>
+            <a:prstDash val="solid"/>
+          </a:ln>
+        </p:spPr>
+      </p:sp>
+      <p:sp>
+        <p:nvSpPr>
+          <p:cNvPr id="9" name="Text 6"/>
+          <p:cNvSpPr/>
+          <p:nvPr/>
+        </p:nvSpPr>
+        <p:spPr>
+          <a:xfrm>
+            <a:off x="5405438" y="6457950"/>
+            <a:ext cx="1381125" cy="171450"/>
+          </a:xfrm>
+          <a:prstGeom prst="rect">
+            <a:avLst/>
+          </a:prstGeom>
+          <a:noFill/>
+          <a:ln/>
+        </p:spPr>
+        <p:txBody>
+          <a:bodyPr wrap="square" lIns="0" tIns="0" rIns="0" bIns="0" rtlCol="0" anchor="t"/>
+          <a:lstStyle/>
+          <a:p>
+            <a:pPr algn="ctr" indent="0" marL="0">
+              <a:buNone/>
+            </a:pPr>
+            <a:r>
+              <a:rPr lang="en-US" sz="1000" b="1" dirty="0">
+                <a:solidFill>
+                  <a:srgbClr val="FFFFFF"/>
+                </a:solidFill>
+                <a:latin typeface="Helvetica Neue" pitchFamily="34" charset="0"/>
+                <a:ea typeface="Helvetica Neue" pitchFamily="34" charset="-122"/>
+                <a:cs typeface="Helvetica Neue" pitchFamily="34" charset="-120"/>
+              </a:rPr>
+              <a:t>INTERNAL ONLY</a:t>
+            </a:r>
+            <a:endParaRPr lang="en-US" sz="1000" dirty="0"/>
+          </a:p>
+        </p:txBody>
+      </p:sp>
+      <p:sp>
+        <p:nvSpPr>
+          <p:cNvPr id="10" name="Text 7"/>
+          <p:cNvSpPr/>
+          <p:nvPr/>
+        </p:nvSpPr>
+        <p:spPr>
+          <a:xfrm>
+            <a:off x="11334750" y="6457950"/>
+            <a:ext cx="457200" cy="171450"/>
+          </a:xfrm>
+          <a:prstGeom prst="rect">
+            <a:avLst/>
+          </a:prstGeom>
+          <a:noFill/>
+          <a:ln/>
+        </p:spPr>
+        <p:txBody>
+          <a:bodyPr wrap="square" lIns="0" tIns="0" rIns="0" bIns="0" rtlCol="0" anchor="t"/>
+          <a:lstStyle/>
+          <a:p>
+            <a:pPr algn="r" indent="0" marL="0">
+              <a:buNone/>
+            </a:pPr>
+            <a:r>
+              <a:rPr lang="en-US" sz="1200" dirty="0">
+                <a:solidFill>
+                  <a:srgbClr val="6C6C8A"/>
+                </a:solidFill>
+                <a:latin typeface="Helvetica Neue" pitchFamily="34" charset="0"/>
+                <a:ea typeface="Helvetica Neue" pitchFamily="34" charset="-122"/>
+                <a:cs typeface="Helvetica Neue" pitchFamily="34" charset="-120"/>
+              </a:rPr>
+              <a:t>15</a:t>
             </a:r>
             <a:endParaRPr lang="en-US" sz="1200" dirty="0"/>
           </a:p>

</xml_diff>